<commit_message>
Add the decision slide the deck was missing, and clear two stale lines
The deck had every result but never stated, in one place, what the research
question is, what the contributions are, and why a reviewer should care. A
professor deciding whether to fund another month should not have to infer that
from result slides. New slide 2 states the question, the contradiction in the
literature that motivates it (CAPL/SoFA open cross-image attention, MIMIC blocks
it, both report gains, nobody explains why), our answer, and the five
contributions with their measured evidence.

Also corrected: slide 10 said the all-of-3 set was still being measured — it is
done, AUC 0.99 to 0.65 — and slide 11 undercounted the pre-registrations at four
with two failures when it is five with three primary-endpoint failures.

Co-Authored-By: Claude Fable 5 <noreply@anthropic.com>
</commit_message>
<xml_diff>
--- a/meeting/SourceDepth_meeting_FINAL_v5.pptx
+++ b/meeting/SourceDepth_meeting_FINAL_v5.pptx
@@ -15,9 +15,10 @@
     <p:sldId id="263" r:id="rId9"/>
     <p:sldId id="264" r:id="rId10"/>
     <p:sldId id="265" r:id="rId11"/>
+    <p:sldId id="266" r:id="rId12"/>
   </p:sldIdLst>
   <p:notesMasterIdLst>
-    <p:notesMasterId r:id="rId12"/>
+    <p:notesMasterId r:id="rId13"/>
   </p:notesMasterIdLst>
   <p:sldSz cx="12192000" cy="6858000"/>
   <p:notesSz cx="6858000" cy="12192000"/>
@@ -599,6 +600,94 @@
           <a:p>
             <a:r>
               <a:rPr lang="en-US" dirty="0"/>
+              <a:t>불리한 것을 먼저 말씀드립니다. 가장 큰 문제는 벤치마크입니다. 지금 질문이 첫 번째 이미지라고 위치를 지목하기 때문에 앞단 모듈이 텍스트만 읽어도 됩니다. 이건 설계 결함이고 바꿔야 합니다.</a:t>
+            </a:r>
+            <a:endParaRPr lang="en-US" dirty="0"/>
+          </a:p>
+        </p:txBody>
+      </p:sp>
+      <p:sp>
+        <p:nvSpPr>
+          <p:cNvPr id="4" name="Slide Number Placeholder 3"/>
+          <p:cNvSpPr>
+            <a:spLocks noGrp="1"/>
+          </p:cNvSpPr>
+          <p:nvPr>
+            <p:ph type="sldNum" sz="quarter" idx="10"/>
+          </p:nvPr>
+        </p:nvSpPr>
+        <p:spPr/>
+        <p:txBody>
+          <a:bodyPr/>
+          <a:lstStyle/>
+          <a:p>
+            <a:fld id="{F7021451-1387-4CA6-816F-3879F97B5CBC}" type="slidenum">
+              <a:rPr lang="en-US"/>
+              <a:t>10</a:t>
+            </a:fld>
+            <a:endParaRPr lang="en-US"/>
+          </a:p>
+        </p:txBody>
+      </p:sp>
+    </p:spTree>
+    <p:extLst>
+      <p:ext uri="{BB962C8B-B14F-4D97-AF65-F5344CB8AC3E}">
+        <p14:creationId xmlns:p14="http://schemas.microsoft.com/office/powerpoint/2010/main" val="1024086991"/>
+      </p:ext>
+    </p:extLst>
+  </p:cSld>
+  <p:clrMapOvr>
+    <a:masterClrMapping/>
+  </p:clrMapOvr>
+</p:notes>
+</file>
+
+<file path=ppt/notesSlides/notesSlide11.xml><?xml version="1.0" encoding="utf-8"?>
+<p:notes xmlns:a="http://schemas.openxmlformats.org/drawingml/2006/main" xmlns:r="http://schemas.openxmlformats.org/officeDocument/2006/relationships" xmlns:p="http://schemas.openxmlformats.org/presentationml/2006/main">
+  <p:cSld>
+    <p:spTree>
+      <p:nvGrpSpPr>
+        <p:cNvPr id="1" name=""/>
+        <p:cNvGrpSpPr/>
+        <p:nvPr/>
+      </p:nvGrpSpPr>
+      <p:grpSpPr>
+        <a:xfrm>
+          <a:off x="0" y="0"/>
+          <a:ext cx="0" cy="0"/>
+          <a:chOff x="0" y="0"/>
+          <a:chExt cx="0" cy="0"/>
+        </a:xfrm>
+      </p:grpSpPr>
+      <p:sp>
+        <p:nvSpPr>
+          <p:cNvPr id="2" name="Slide Image Placeholder 1"/>
+          <p:cNvSpPr>
+            <a:spLocks noGrp="1" noRot="1" noChangeAspect="1"/>
+          </p:cNvSpPr>
+          <p:nvPr>
+            <p:ph type="sldImg"/>
+          </p:nvPr>
+        </p:nvSpPr>
+        <p:spPr/>
+      </p:sp>
+      <p:sp>
+        <p:nvSpPr>
+          <p:cNvPr id="3" name="Notes Placeholder 2"/>
+          <p:cNvSpPr>
+            <a:spLocks noGrp="1"/>
+          </p:cNvSpPr>
+          <p:nvPr>
+            <p:ph type="body" idx="1"/>
+          </p:nvPr>
+        </p:nvSpPr>
+        <p:spPr/>
+        <p:txBody>
+          <a:bodyPr/>
+          <a:lstStyle/>
+          <a:p>
+            <a:r>
+              <a:rPr lang="en-US" dirty="0"/>
               <a:t>4주 계획입니다. 가장 중요한 건 2주차입니다. 공개 벤치마크에서 재현되지 않으면 접겠습니다. 지금까지 사전 등록을 네 번 했고 그중 두 번은 실패로 기록했습니다. 이번에도 같은 방식으로 하겠습니다.</a:t>
             </a:r>
             <a:endParaRPr lang="en-US" dirty="0"/>
@@ -622,7 +711,7 @@
           <a:p>
             <a:fld id="{F7021451-1387-4CA6-816F-3879F97B5CBC}" type="slidenum">
               <a:rPr lang="en-US"/>
-              <a:t>10</a:t>
+              <a:t>11</a:t>
             </a:fld>
             <a:endParaRPr lang="en-US"/>
           </a:p>
@@ -687,7 +776,7 @@
           <a:p>
             <a:r>
               <a:rPr lang="en-US" dirty="0"/>
-              <a:t>설계의 핵심은 두 가지입니다. 첫째, 오염 압력이 양방향입니다 — 한쪽 방향만 보면 7B에서 현상을 놓칩니다. 실제로 저희가 처음에 그 실수를 했습니다. 둘째, 지표를 AUC로 잡았습니다. 정확도만 보면 예/아니오 비율이 이동한 것을 판별력 개선으로 착각합니다.</a:t>
+              <a:t>이 슬라이드가 판단용입니다. 기존 연구가 정반대 처방을 냈는데 양쪽 다 개선을 보고했습니다. 아무도 그 이유를 설명하지 못했고, 저희가 경로를 나눠서 재니 둘 다 맞았다는 게 나왔습니다. 기여는 다섯 가지이고 전부 측정된 숫자입니다. 특히 C2가 새롭습니다 — 무관한 이미지를 지우는 것보다 질문의 읽기만 끊는 게 낫다는 건 기존 어느 진영과도 다른 처방입니다.</a:t>
             </a:r>
             <a:endParaRPr lang="en-US" dirty="0"/>
           </a:p>
@@ -775,7 +864,7 @@
           <a:p>
             <a:r>
               <a:rPr lang="en-US" dirty="0"/>
-              <a:t>왼쪽 표를 보시면 방해 이미지가 늘수록 판별력이 단조 감소합니다. 3장이면 0.521, 사실상 우연입니다. 그런데 차단하면 어느 경우든 0.904로 돌아옵니다. 회복률이 방해 수와 무관하게 99%라는 게 중요합니다 — 정보가 손상된 게 아니라 가려져 있었다는 뜻입니다.</a:t>
+              <a:t>설계의 핵심은 두 가지입니다. 첫째, 오염 압력이 양방향입니다 — 한쪽 방향만 보면 7B에서 현상을 놓칩니다. 실제로 저희가 처음에 그 실수를 했습니다. 둘째, 지표를 AUC로 잡았습니다. 정확도만 보면 예/아니오 비율이 이동한 것을 판별력 개선으로 착각합니다.</a:t>
             </a:r>
             <a:endParaRPr lang="en-US" dirty="0"/>
           </a:p>
@@ -863,7 +952,7 @@
           <a:p>
             <a:r>
               <a:rPr lang="en-US" dirty="0"/>
-              <a:t>이 슬라이드가 핵심입니다. 두 배치에서 각각 쟀습니다. 뒤집은 배치에서는 관련 이미지가 방해 이미지를 볼 수 있으므로 표현 오염 경로가 실제로 존재합니다. 그런데 그 경로를 끊으면 파국적으로 나빠집니다. 즉 이미지끼리 정보를 주고받는 것은 오염원이 아니라 보호막입니다. 그리고 더 중요한 건 오른쪽입니다. 질문의 읽기 경로만 끊는 것이 무관 이미지를 통째로 지우는 것보다 낫습니다. 지우면 유익한 맥락화까지 잃기 때문입니다. 사전에 적어둔 예측 두 개가 모두 틀렸는데, 틀린 방향이 저희 결론을 오히려 강하게 만들었습니다.</a:t>
+              <a:t>왼쪽 표를 보시면 방해 이미지가 늘수록 판별력이 단조 감소합니다. 3장이면 0.521, 사실상 우연입니다. 그런데 차단하면 어느 경우든 0.904로 돌아옵니다. 회복률이 방해 수와 무관하게 99%라는 게 중요합니다 — 정보가 손상된 게 아니라 가려져 있었다는 뜻입니다.</a:t>
             </a:r>
             <a:endParaRPr lang="en-US" dirty="0"/>
           </a:p>
@@ -951,7 +1040,7 @@
           <a:p>
             <a:r>
               <a:rPr lang="en-US" dirty="0"/>
-              <a:t>교수님께서 물어보실 만한 것을 미리 답해두었습니다. CLIP 같은 작은 모듈로 앞에서 걸러내면 되지 않느냐는 질문인데, 두 가지로 답합니다. 첫째, 최적 정책이 질문 유형에 따라 다릅니다. 둘째, 앞단 selector의 오판은 복구가 안 됩니다.</a:t>
+              <a:t>이 슬라이드가 핵심입니다. 두 배치에서 각각 쟀습니다. 뒤집은 배치에서는 관련 이미지가 방해 이미지를 볼 수 있으므로 표현 오염 경로가 실제로 존재합니다. 그런데 그 경로를 끊으면 파국적으로 나빠집니다. 즉 이미지끼리 정보를 주고받는 것은 오염원이 아니라 보호막입니다. 그리고 더 중요한 건 오른쪽입니다. 질문의 읽기 경로만 끊는 것이 무관 이미지를 통째로 지우는 것보다 낫습니다. 지우면 유익한 맥락화까지 잃기 때문입니다. 사전에 적어둔 예측 두 개가 모두 틀렸는데, 틀린 방향이 저희 결론을 오히려 강하게 만들었습니다.</a:t>
             </a:r>
             <a:endParaRPr lang="en-US" dirty="0"/>
           </a:p>
@@ -1039,7 +1128,7 @@
           <a:p>
             <a:r>
               <a:rPr lang="en-US" dirty="0"/>
-              <a:t>선행연구를 네 축으로 조사했고 고위협 논문 다섯 편은 원문까지 확인했습니다. 그 결과 처음에 novelty로 생각했던 세 가지는 쓸 수 없다는 걸 알았습니다. 대신 더 좁고 확실한 자리가 열렸습니다. 특히 CAPL과 SoFA는 attention을 여는 방향, MIMIC은 막는 방향으로 정반대 처방을 냈는데, 저희 경로 분해가 이 모순을 설명합니다.</a:t>
+              <a:t>교수님께서 물어보실 만한 것을 미리 답해두었습니다. CLIP 같은 작은 모듈로 앞에서 걸러내면 되지 않느냐는 질문인데, 두 가지로 답합니다. 첫째, 최적 정책이 질문 유형에 따라 다릅니다. 둘째, 앞단 selector의 오판은 복구가 안 됩니다.</a:t>
             </a:r>
             <a:endParaRPr lang="en-US" dirty="0"/>
           </a:p>
@@ -1127,7 +1216,7 @@
           <a:p>
             <a:r>
               <a:rPr lang="en-US" dirty="0"/>
-              <a:t>여기가 그동안 막혀 있던 부분입니다. attention으로 관련 이미지를 판정하려는 시도는 계속 실패했습니다. 위치 편향 때문이었고, 선행연구가 제시한 RoPE 제거 처방을 적용해도 안 됐습니다. 그래서 신호를 완전히 바꿨습니다. 이미지를 하나씩 빼보고 답이 가장 크게 움직이는 것을 관련 이미지로 봅니다. 위치를 아예 참조하지 않으니 위치 편향이 원천적으로 불가능합니다.</a:t>
+              <a:t>선행연구를 네 축으로 조사했고 고위협 논문 다섯 편은 원문까지 확인했습니다. 그 결과 처음에 novelty로 생각했던 세 가지는 쓸 수 없다는 걸 알았습니다. 대신 더 좁고 확실한 자리가 열렸습니다. 특히 CAPL과 SoFA는 attention을 여는 방향, MIMIC은 막는 방향으로 정반대 처방을 냈는데, 저희 경로 분해가 이 모순을 설명합니다.</a:t>
             </a:r>
             <a:endParaRPr lang="en-US" dirty="0"/>
           </a:p>
@@ -1215,7 +1304,7 @@
           <a:p>
             <a:r>
               <a:rPr lang="en-US" dirty="0"/>
-              <a:t>방법은 여러 개를 시험했고 트레이드오프가 분명합니다. 하드 차단은 계산을 줄이지만 오라클이 필요합니다. 대조 디코딩은 정확도가 가장 좋지만 forward가 두 번입니다. 반사실 컨트롤러는 오라클이 필요 없지만 N+1번입니다. 그리고 처음에 생각했던 negative attention은 폐기합니다. 조사해보니 GPAM 계열은 전부 아키텍처 변경과 학습이 필요하고, 학습 없이 할 수 있는 건 결국 저희 마스크의 연속판이었습니다.</a:t>
+              <a:t>여기가 그동안 막혀 있던 부분입니다. attention으로 관련 이미지를 판정하려는 시도는 계속 실패했습니다. 위치 편향 때문이었고, 선행연구가 제시한 RoPE 제거 처방을 적용해도 안 됐습니다. 그래서 신호를 완전히 바꿨습니다. 이미지를 하나씩 빼보고 답이 가장 크게 움직이는 것을 관련 이미지로 봅니다. 위치를 아예 참조하지 않으니 위치 편향이 원천적으로 불가능합니다.</a:t>
             </a:r>
             <a:endParaRPr lang="en-US" dirty="0"/>
           </a:p>
@@ -1303,7 +1392,7 @@
           <a:p>
             <a:r>
               <a:rPr lang="en-US" dirty="0"/>
-              <a:t>불리한 것을 먼저 말씀드립니다. 가장 큰 문제는 벤치마크입니다. 지금 질문이 첫 번째 이미지라고 위치를 지목하기 때문에 앞단 모듈이 텍스트만 읽어도 됩니다. 이건 설계 결함이고 바꿔야 합니다.</a:t>
+              <a:t>방법은 여러 개를 시험했고 트레이드오프가 분명합니다. 하드 차단은 계산을 줄이지만 오라클이 필요합니다. 대조 디코딩은 정확도가 가장 좋지만 forward가 두 번입니다. 반사실 컨트롤러는 오라클이 필요 없지만 N+1번입니다. 그리고 처음에 생각했던 negative attention은 폐기합니다. 조사해보니 GPAM 계열은 전부 아키텍처 변경과 학습이 필요하고, 학습 없이 할 수 있는 건 결국 저희 마스크의 연속판이었습니다.</a:t>
             </a:r>
             <a:endParaRPr lang="en-US" dirty="0"/>
           </a:p>
@@ -2388,6 +2477,848 @@
 <file path=ppt/slides/slide10.xml><?xml version="1.0" encoding="utf-8"?>
 <p:sld xmlns:a="http://schemas.openxmlformats.org/drawingml/2006/main" xmlns:r="http://schemas.openxmlformats.org/officeDocument/2006/relationships" xmlns:p="http://schemas.openxmlformats.org/presentationml/2006/main">
   <p:cSld name="Slide 10">
+    <p:spTree>
+      <p:nvGrpSpPr>
+        <p:cNvPr id="1" name=""/>
+        <p:cNvGrpSpPr/>
+        <p:nvPr/>
+      </p:nvGrpSpPr>
+      <p:grpSpPr>
+        <a:xfrm>
+          <a:off x="0" y="0"/>
+          <a:ext cx="0" cy="0"/>
+          <a:chOff x="0" y="0"/>
+          <a:chExt cx="0" cy="0"/>
+        </a:xfrm>
+      </p:grpSpPr>
+      <p:sp>
+        <p:nvSpPr>
+          <p:cNvPr id="2" name="Text 0"/>
+          <p:cNvSpPr/>
+          <p:nvPr/>
+        </p:nvSpPr>
+        <p:spPr>
+          <a:xfrm>
+            <a:off x="502920" y="237744"/>
+            <a:ext cx="10515600" cy="274320"/>
+          </a:xfrm>
+          <a:prstGeom prst="rect">
+            <a:avLst/>
+          </a:prstGeom>
+          <a:noFill/>
+          <a:ln/>
+        </p:spPr>
+        <p:txBody>
+          <a:bodyPr wrap="square" lIns="0" tIns="0" rIns="0" bIns="0" rtlCol="0" anchor="ctr"/>
+          <a:lstStyle/>
+          <a:p>
+            <a:pPr indent="0" marL="0">
+              <a:buNone/>
+            </a:pPr>
+            <a:r>
+              <a:rPr lang="en-US" sz="1100" b="1" dirty="0">
+                <a:solidFill>
+                  <a:srgbClr val="1F77B4"/>
+                </a:solidFill>
+                <a:latin typeface="Arial" pitchFamily="34" charset="0"/>
+                <a:ea typeface="Arial" pitchFamily="34" charset="-122"/>
+                <a:cs typeface="Arial" pitchFamily="34" charset="-120"/>
+              </a:rPr>
+              <a:t>정직한 한계</a:t>
+            </a:r>
+            <a:endParaRPr lang="en-US" sz="1100" dirty="0"/>
+          </a:p>
+        </p:txBody>
+      </p:sp>
+      <p:sp>
+        <p:nvSpPr>
+          <p:cNvPr id="3" name="Text 1"/>
+          <p:cNvSpPr/>
+          <p:nvPr/>
+        </p:nvSpPr>
+        <p:spPr>
+          <a:xfrm>
+            <a:off x="502920" y="493776"/>
+            <a:ext cx="11155680" cy="658368"/>
+          </a:xfrm>
+          <a:prstGeom prst="rect">
+            <a:avLst/>
+          </a:prstGeom>
+          <a:noFill/>
+          <a:ln/>
+        </p:spPr>
+        <p:txBody>
+          <a:bodyPr wrap="square" lIns="0" tIns="0" rIns="0" bIns="0" rtlCol="0" anchor="ctr"/>
+          <a:lstStyle/>
+          <a:p>
+            <a:pPr indent="0" marL="0">
+              <a:buNone/>
+            </a:pPr>
+            <a:r>
+              <a:rPr lang="en-US" sz="2100" b="1" dirty="0">
+                <a:solidFill>
+                  <a:srgbClr val="1F3B57"/>
+                </a:solidFill>
+                <a:latin typeface="Arial" pitchFamily="34" charset="0"/>
+                <a:ea typeface="Arial" pitchFamily="34" charset="-122"/>
+                <a:cs typeface="Arial" pitchFamily="34" charset="-120"/>
+              </a:rPr>
+              <a:t>지금 이 연구를 무너뜨릴 수 있는 것 세 가지</a:t>
+            </a:r>
+            <a:endParaRPr lang="en-US" sz="2100" dirty="0"/>
+          </a:p>
+        </p:txBody>
+      </p:sp>
+      <p:sp>
+        <p:nvSpPr>
+          <p:cNvPr id="4" name="Shape 2"/>
+          <p:cNvSpPr/>
+          <p:nvPr/>
+        </p:nvSpPr>
+        <p:spPr>
+          <a:xfrm>
+            <a:off x="502920" y="1298448"/>
+            <a:ext cx="11201400" cy="1408176"/>
+          </a:xfrm>
+          <a:prstGeom prst="roundRect">
+            <a:avLst>
+              <a:gd name="adj" fmla="val 5195"/>
+            </a:avLst>
+          </a:prstGeom>
+          <a:solidFill>
+            <a:srgbClr val="FBEAEA"/>
+          </a:solidFill>
+          <a:ln w="12700">
+            <a:solidFill>
+              <a:srgbClr val="D62728"/>
+            </a:solidFill>
+            <a:prstDash val="solid"/>
+          </a:ln>
+        </p:spPr>
+      </p:sp>
+      <p:sp>
+        <p:nvSpPr>
+          <p:cNvPr id="5" name="Shape 3"/>
+          <p:cNvSpPr/>
+          <p:nvPr/>
+        </p:nvSpPr>
+        <p:spPr>
+          <a:xfrm>
+            <a:off x="749808" y="1463040"/>
+            <a:ext cx="402336" cy="402336"/>
+          </a:xfrm>
+          <a:prstGeom prst="ellipse">
+            <a:avLst/>
+          </a:prstGeom>
+          <a:solidFill>
+            <a:srgbClr val="D62728"/>
+          </a:solidFill>
+          <a:ln/>
+        </p:spPr>
+      </p:sp>
+      <p:sp>
+        <p:nvSpPr>
+          <p:cNvPr id="6" name="Text 4"/>
+          <p:cNvSpPr/>
+          <p:nvPr/>
+        </p:nvSpPr>
+        <p:spPr>
+          <a:xfrm>
+            <a:off x="749808" y="1463040"/>
+            <a:ext cx="402336" cy="402336"/>
+          </a:xfrm>
+          <a:prstGeom prst="rect">
+            <a:avLst/>
+          </a:prstGeom>
+          <a:noFill/>
+          <a:ln/>
+        </p:spPr>
+        <p:txBody>
+          <a:bodyPr wrap="square" lIns="0" tIns="0" rIns="0" bIns="0" rtlCol="0" anchor="ctr"/>
+          <a:lstStyle/>
+          <a:p>
+            <a:pPr algn="ctr" indent="0" marL="0">
+              <a:buNone/>
+            </a:pPr>
+            <a:r>
+              <a:rPr lang="en-US" sz="1300" b="1" dirty="0">
+                <a:solidFill>
+                  <a:srgbClr val="FFFFFF"/>
+                </a:solidFill>
+                <a:latin typeface="Arial" pitchFamily="34" charset="0"/>
+                <a:ea typeface="Arial" pitchFamily="34" charset="-122"/>
+                <a:cs typeface="Arial" pitchFamily="34" charset="-120"/>
+              </a:rPr>
+              <a:t>1</a:t>
+            </a:r>
+            <a:endParaRPr lang="en-US" sz="1300" dirty="0"/>
+          </a:p>
+        </p:txBody>
+      </p:sp>
+      <p:sp>
+        <p:nvSpPr>
+          <p:cNvPr id="7" name="Text 5"/>
+          <p:cNvSpPr/>
+          <p:nvPr/>
+        </p:nvSpPr>
+        <p:spPr>
+          <a:xfrm>
+            <a:off x="1316736" y="1444752"/>
+            <a:ext cx="10149840" cy="274320"/>
+          </a:xfrm>
+          <a:prstGeom prst="rect">
+            <a:avLst/>
+          </a:prstGeom>
+          <a:noFill/>
+          <a:ln/>
+        </p:spPr>
+        <p:txBody>
+          <a:bodyPr wrap="square" lIns="0" tIns="0" rIns="0" bIns="0" rtlCol="0" anchor="ctr"/>
+          <a:lstStyle/>
+          <a:p>
+            <a:pPr indent="0" marL="0">
+              <a:buNone/>
+            </a:pPr>
+            <a:r>
+              <a:rPr lang="en-US" sz="1300" b="1" dirty="0">
+                <a:solidFill>
+                  <a:srgbClr val="1F3B57"/>
+                </a:solidFill>
+                <a:latin typeface="Arial" pitchFamily="34" charset="0"/>
+                <a:ea typeface="Arial" pitchFamily="34" charset="-122"/>
+                <a:cs typeface="Arial" pitchFamily="34" charset="-120"/>
+              </a:rPr>
+              <a:t>벤치마크가 위치로 대상을 지목한다</a:t>
+            </a:r>
+            <a:endParaRPr lang="en-US" sz="1300" dirty="0"/>
+          </a:p>
+        </p:txBody>
+      </p:sp>
+      <p:sp>
+        <p:nvSpPr>
+          <p:cNvPr id="8" name="Text 6"/>
+          <p:cNvSpPr/>
+          <p:nvPr/>
+        </p:nvSpPr>
+        <p:spPr>
+          <a:xfrm>
+            <a:off x="1316736" y="1755648"/>
+            <a:ext cx="10149840" cy="548640"/>
+          </a:xfrm>
+          <a:prstGeom prst="rect">
+            <a:avLst/>
+          </a:prstGeom>
+          <a:noFill/>
+          <a:ln/>
+        </p:spPr>
+        <p:txBody>
+          <a:bodyPr wrap="square" lIns="0" tIns="0" rIns="0" bIns="0" rtlCol="0" anchor="ctr"/>
+          <a:lstStyle/>
+          <a:p>
+            <a:pPr indent="0" marL="0">
+              <a:lnSpc>
+                <a:spcPct val="115000"/>
+              </a:lnSpc>
+              <a:buNone/>
+            </a:pPr>
+            <a:r>
+              <a:rPr lang="en-US" sz="1100" dirty="0">
+                <a:solidFill>
+                  <a:srgbClr val="1F3B57"/>
+                </a:solidFill>
+                <a:latin typeface="Arial" pitchFamily="34" charset="0"/>
+                <a:ea typeface="Arial" pitchFamily="34" charset="-122"/>
+                <a:cs typeface="Arial" pitchFamily="34" charset="-120"/>
+              </a:rPr>
+              <a:t>질문이 "첫 번째 이미지에"로 시작하므로, 앞단 모듈이 텍스트만 파싱해도 100% 맞힙니다.</a:t>
+            </a:r>
+            <a:endParaRPr lang="en-US" sz="1100" dirty="0"/>
+          </a:p>
+          <a:p>
+            <a:pPr indent="0" marL="0">
+              <a:lnSpc>
+                <a:spcPct val="115000"/>
+              </a:lnSpc>
+              <a:buNone/>
+            </a:pPr>
+            <a:r>
+              <a:rPr lang="en-US" sz="1100" dirty="0">
+                <a:solidFill>
+                  <a:srgbClr val="1F3B57"/>
+                </a:solidFill>
+                <a:latin typeface="Arial" pitchFamily="34" charset="0"/>
+                <a:ea typeface="Arial" pitchFamily="34" charset="-122"/>
+                <a:cs typeface="Arial" pitchFamily="34" charset="-120"/>
+              </a:rPr>
+              <a:t>현 벤치마크로는 '내부 개입이어야 하는 이유'를 증명할 수 없습니다.</a:t>
+            </a:r>
+            <a:endParaRPr lang="en-US" sz="1100" dirty="0"/>
+          </a:p>
+        </p:txBody>
+      </p:sp>
+      <p:sp>
+        <p:nvSpPr>
+          <p:cNvPr id="9" name="Text 7"/>
+          <p:cNvSpPr/>
+          <p:nvPr/>
+        </p:nvSpPr>
+        <p:spPr>
+          <a:xfrm>
+            <a:off x="1316736" y="2340864"/>
+            <a:ext cx="10149840" cy="274320"/>
+          </a:xfrm>
+          <a:prstGeom prst="rect">
+            <a:avLst/>
+          </a:prstGeom>
+          <a:noFill/>
+          <a:ln/>
+        </p:spPr>
+        <p:txBody>
+          <a:bodyPr wrap="square" lIns="0" tIns="0" rIns="0" bIns="0" rtlCol="0" anchor="ctr"/>
+          <a:lstStyle/>
+          <a:p>
+            <a:pPr indent="0" marL="0">
+              <a:buNone/>
+            </a:pPr>
+            <a:r>
+              <a:rPr lang="en-US" sz="1100" b="1" dirty="0">
+                <a:solidFill>
+                  <a:srgbClr val="2E8B57"/>
+                </a:solidFill>
+                <a:latin typeface="Arial" pitchFamily="34" charset="0"/>
+                <a:ea typeface="Arial" pitchFamily="34" charset="-122"/>
+                <a:cs typeface="Arial" pitchFamily="34" charset="-120"/>
+              </a:rPr>
+              <a:t>대응: all-of-3 세트를 만들어 측정 완료 (AUC 0.99 → 0.65로 천장 제거). 다음은 관련도가 추론의 결과인 질문</a:t>
+            </a:r>
+            <a:endParaRPr lang="en-US" sz="1100" dirty="0"/>
+          </a:p>
+        </p:txBody>
+      </p:sp>
+      <p:sp>
+        <p:nvSpPr>
+          <p:cNvPr id="10" name="Shape 8"/>
+          <p:cNvSpPr/>
+          <p:nvPr/>
+        </p:nvSpPr>
+        <p:spPr>
+          <a:xfrm>
+            <a:off x="502920" y="2834640"/>
+            <a:ext cx="11201400" cy="1408176"/>
+          </a:xfrm>
+          <a:prstGeom prst="roundRect">
+            <a:avLst>
+              <a:gd name="adj" fmla="val 5195"/>
+            </a:avLst>
+          </a:prstGeom>
+          <a:solidFill>
+            <a:srgbClr val="FBEAEA"/>
+          </a:solidFill>
+          <a:ln w="12700">
+            <a:solidFill>
+              <a:srgbClr val="D62728"/>
+            </a:solidFill>
+            <a:prstDash val="solid"/>
+          </a:ln>
+        </p:spPr>
+      </p:sp>
+      <p:sp>
+        <p:nvSpPr>
+          <p:cNvPr id="11" name="Shape 9"/>
+          <p:cNvSpPr/>
+          <p:nvPr/>
+        </p:nvSpPr>
+        <p:spPr>
+          <a:xfrm>
+            <a:off x="749808" y="2999232"/>
+            <a:ext cx="402336" cy="402336"/>
+          </a:xfrm>
+          <a:prstGeom prst="ellipse">
+            <a:avLst/>
+          </a:prstGeom>
+          <a:solidFill>
+            <a:srgbClr val="D62728"/>
+          </a:solidFill>
+          <a:ln/>
+        </p:spPr>
+      </p:sp>
+      <p:sp>
+        <p:nvSpPr>
+          <p:cNvPr id="12" name="Text 10"/>
+          <p:cNvSpPr/>
+          <p:nvPr/>
+        </p:nvSpPr>
+        <p:spPr>
+          <a:xfrm>
+            <a:off x="749808" y="2999232"/>
+            <a:ext cx="402336" cy="402336"/>
+          </a:xfrm>
+          <a:prstGeom prst="rect">
+            <a:avLst/>
+          </a:prstGeom>
+          <a:noFill/>
+          <a:ln/>
+        </p:spPr>
+        <p:txBody>
+          <a:bodyPr wrap="square" lIns="0" tIns="0" rIns="0" bIns="0" rtlCol="0" anchor="ctr"/>
+          <a:lstStyle/>
+          <a:p>
+            <a:pPr algn="ctr" indent="0" marL="0">
+              <a:buNone/>
+            </a:pPr>
+            <a:r>
+              <a:rPr lang="en-US" sz="1300" b="1" dirty="0">
+                <a:solidFill>
+                  <a:srgbClr val="FFFFFF"/>
+                </a:solidFill>
+                <a:latin typeface="Arial" pitchFamily="34" charset="0"/>
+                <a:ea typeface="Arial" pitchFamily="34" charset="-122"/>
+                <a:cs typeface="Arial" pitchFamily="34" charset="-120"/>
+              </a:rPr>
+              <a:t>2</a:t>
+            </a:r>
+            <a:endParaRPr lang="en-US" sz="1300" dirty="0"/>
+          </a:p>
+        </p:txBody>
+      </p:sp>
+      <p:sp>
+        <p:nvSpPr>
+          <p:cNvPr id="13" name="Text 11"/>
+          <p:cNvSpPr/>
+          <p:nvPr/>
+        </p:nvSpPr>
+        <p:spPr>
+          <a:xfrm>
+            <a:off x="1316736" y="2980944"/>
+            <a:ext cx="10149840" cy="274320"/>
+          </a:xfrm>
+          <a:prstGeom prst="rect">
+            <a:avLst/>
+          </a:prstGeom>
+          <a:noFill/>
+          <a:ln/>
+        </p:spPr>
+        <p:txBody>
+          <a:bodyPr wrap="square" lIns="0" tIns="0" rIns="0" bIns="0" rtlCol="0" anchor="ctr"/>
+          <a:lstStyle/>
+          <a:p>
+            <a:pPr indent="0" marL="0">
+              <a:buNone/>
+            </a:pPr>
+            <a:r>
+              <a:rPr lang="en-US" sz="1300" b="1" dirty="0">
+                <a:solidFill>
+                  <a:srgbClr val="1F3B57"/>
+                </a:solidFill>
+                <a:latin typeface="Arial" pitchFamily="34" charset="0"/>
+                <a:ea typeface="Arial" pitchFamily="34" charset="-122"/>
+                <a:cs typeface="Arial" pitchFamily="34" charset="-120"/>
+              </a:rPr>
+              <a:t>실현 성능이 아직 오라클 상한에 크게 못 미친다</a:t>
+            </a:r>
+            <a:endParaRPr lang="en-US" sz="1300" dirty="0"/>
+          </a:p>
+        </p:txBody>
+      </p:sp>
+      <p:sp>
+        <p:nvSpPr>
+          <p:cNvPr id="14" name="Text 12"/>
+          <p:cNvSpPr/>
+          <p:nvPr/>
+        </p:nvSpPr>
+        <p:spPr>
+          <a:xfrm>
+            <a:off x="1316736" y="3291840"/>
+            <a:ext cx="10149840" cy="548640"/>
+          </a:xfrm>
+          <a:prstGeom prst="rect">
+            <a:avLst/>
+          </a:prstGeom>
+          <a:noFill/>
+          <a:ln/>
+        </p:spPr>
+        <p:txBody>
+          <a:bodyPr wrap="square" lIns="0" tIns="0" rIns="0" bIns="0" rtlCol="0" anchor="ctr"/>
+          <a:lstStyle/>
+          <a:p>
+            <a:pPr indent="0" marL="0">
+              <a:lnSpc>
+                <a:spcPct val="115000"/>
+              </a:lnSpc>
+              <a:buNone/>
+            </a:pPr>
+            <a:r>
+              <a:rPr lang="en-US" sz="1100" dirty="0">
+                <a:solidFill>
+                  <a:srgbClr val="1F3B57"/>
+                </a:solidFill>
+                <a:latin typeface="Arial" pitchFamily="34" charset="0"/>
+                <a:ea typeface="Arial" pitchFamily="34" charset="-122"/>
+                <a:cs typeface="Arial" pitchFamily="34" charset="-120"/>
+              </a:rPr>
+              <a:t>N=3에서 오라클 0.904 vs 실현 0.703. 손상의 절반만 회수합니다.</a:t>
+            </a:r>
+            <a:endParaRPr lang="en-US" sz="1100" dirty="0"/>
+          </a:p>
+          <a:p>
+            <a:pPr indent="0" marL="0">
+              <a:lnSpc>
+                <a:spcPct val="115000"/>
+              </a:lnSpc>
+              <a:buNone/>
+            </a:pPr>
+            <a:r>
+              <a:rPr lang="en-US" sz="1100" dirty="0">
+                <a:solidFill>
+                  <a:srgbClr val="1F3B57"/>
+                </a:solidFill>
+                <a:latin typeface="Arial" pitchFamily="34" charset="0"/>
+                <a:ea typeface="Arial" pitchFamily="34" charset="-122"/>
+                <a:cs typeface="Arial" pitchFamily="34" charset="-120"/>
+              </a:rPr>
+              <a:t>그리고 forward N+1회라 효율 이득이 없습니다.</a:t>
+            </a:r>
+            <a:endParaRPr lang="en-US" sz="1100" dirty="0"/>
+          </a:p>
+        </p:txBody>
+      </p:sp>
+      <p:sp>
+        <p:nvSpPr>
+          <p:cNvPr id="15" name="Text 13"/>
+          <p:cNvSpPr/>
+          <p:nvPr/>
+        </p:nvSpPr>
+        <p:spPr>
+          <a:xfrm>
+            <a:off x="1316736" y="3877056"/>
+            <a:ext cx="10149840" cy="274320"/>
+          </a:xfrm>
+          <a:prstGeom prst="rect">
+            <a:avLst/>
+          </a:prstGeom>
+          <a:noFill/>
+          <a:ln/>
+        </p:spPr>
+        <p:txBody>
+          <a:bodyPr wrap="square" lIns="0" tIns="0" rIns="0" bIns="0" rtlCol="0" anchor="ctr"/>
+          <a:lstStyle/>
+          <a:p>
+            <a:pPr indent="0" marL="0">
+              <a:buNone/>
+            </a:pPr>
+            <a:r>
+              <a:rPr lang="en-US" sz="1100" b="1" dirty="0">
+                <a:solidFill>
+                  <a:srgbClr val="2E8B57"/>
+                </a:solidFill>
+                <a:latin typeface="Arial" pitchFamily="34" charset="0"/>
+                <a:ea typeface="Arial" pitchFamily="34" charset="-122"/>
+                <a:cs typeface="Arial" pitchFamily="34" charset="-120"/>
+              </a:rPr>
+              <a:t>대응: λ 스윕 측정 완료 — λ=4에서 손상의 74% 회수. 컨트롤러 신호 개선이 다음</a:t>
+            </a:r>
+            <a:endParaRPr lang="en-US" sz="1100" dirty="0"/>
+          </a:p>
+        </p:txBody>
+      </p:sp>
+      <p:sp>
+        <p:nvSpPr>
+          <p:cNvPr id="16" name="Shape 14"/>
+          <p:cNvSpPr/>
+          <p:nvPr/>
+        </p:nvSpPr>
+        <p:spPr>
+          <a:xfrm>
+            <a:off x="502920" y="4370832"/>
+            <a:ext cx="11201400" cy="1408176"/>
+          </a:xfrm>
+          <a:prstGeom prst="roundRect">
+            <a:avLst>
+              <a:gd name="adj" fmla="val 5195"/>
+            </a:avLst>
+          </a:prstGeom>
+          <a:solidFill>
+            <a:srgbClr val="FBEAEA"/>
+          </a:solidFill>
+          <a:ln w="12700">
+            <a:solidFill>
+              <a:srgbClr val="D62728"/>
+            </a:solidFill>
+            <a:prstDash val="solid"/>
+          </a:ln>
+        </p:spPr>
+      </p:sp>
+      <p:sp>
+        <p:nvSpPr>
+          <p:cNvPr id="17" name="Shape 15"/>
+          <p:cNvSpPr/>
+          <p:nvPr/>
+        </p:nvSpPr>
+        <p:spPr>
+          <a:xfrm>
+            <a:off x="749808" y="4535424"/>
+            <a:ext cx="402336" cy="402336"/>
+          </a:xfrm>
+          <a:prstGeom prst="ellipse">
+            <a:avLst/>
+          </a:prstGeom>
+          <a:solidFill>
+            <a:srgbClr val="D62728"/>
+          </a:solidFill>
+          <a:ln/>
+        </p:spPr>
+      </p:sp>
+      <p:sp>
+        <p:nvSpPr>
+          <p:cNvPr id="18" name="Text 16"/>
+          <p:cNvSpPr/>
+          <p:nvPr/>
+        </p:nvSpPr>
+        <p:spPr>
+          <a:xfrm>
+            <a:off x="749808" y="4535424"/>
+            <a:ext cx="402336" cy="402336"/>
+          </a:xfrm>
+          <a:prstGeom prst="rect">
+            <a:avLst/>
+          </a:prstGeom>
+          <a:noFill/>
+          <a:ln/>
+        </p:spPr>
+        <p:txBody>
+          <a:bodyPr wrap="square" lIns="0" tIns="0" rIns="0" bIns="0" rtlCol="0" anchor="ctr"/>
+          <a:lstStyle/>
+          <a:p>
+            <a:pPr algn="ctr" indent="0" marL="0">
+              <a:buNone/>
+            </a:pPr>
+            <a:r>
+              <a:rPr lang="en-US" sz="1300" b="1" dirty="0">
+                <a:solidFill>
+                  <a:srgbClr val="FFFFFF"/>
+                </a:solidFill>
+                <a:latin typeface="Arial" pitchFamily="34" charset="0"/>
+                <a:ea typeface="Arial" pitchFamily="34" charset="-122"/>
+                <a:cs typeface="Arial" pitchFamily="34" charset="-120"/>
+              </a:rPr>
+              <a:t>3</a:t>
+            </a:r>
+            <a:endParaRPr lang="en-US" sz="1300" dirty="0"/>
+          </a:p>
+        </p:txBody>
+      </p:sp>
+      <p:sp>
+        <p:nvSpPr>
+          <p:cNvPr id="19" name="Text 17"/>
+          <p:cNvSpPr/>
+          <p:nvPr/>
+        </p:nvSpPr>
+        <p:spPr>
+          <a:xfrm>
+            <a:off x="1316736" y="4517136"/>
+            <a:ext cx="10149840" cy="274320"/>
+          </a:xfrm>
+          <a:prstGeom prst="rect">
+            <a:avLst/>
+          </a:prstGeom>
+          <a:noFill/>
+          <a:ln/>
+        </p:spPr>
+        <p:txBody>
+          <a:bodyPr wrap="square" lIns="0" tIns="0" rIns="0" bIns="0" rtlCol="0" anchor="ctr"/>
+          <a:lstStyle/>
+          <a:p>
+            <a:pPr indent="0" marL="0">
+              <a:buNone/>
+            </a:pPr>
+            <a:r>
+              <a:rPr lang="en-US" sz="1300" b="1" dirty="0">
+                <a:solidFill>
+                  <a:srgbClr val="1F3B57"/>
+                </a:solidFill>
+                <a:latin typeface="Arial" pitchFamily="34" charset="0"/>
+                <a:ea typeface="Arial" pitchFamily="34" charset="-122"/>
+                <a:cs typeface="Arial" pitchFamily="34" charset="-120"/>
+              </a:rPr>
+              <a:t>표준 벤치마크에서 아직 보이지 않았다</a:t>
+            </a:r>
+            <a:endParaRPr lang="en-US" sz="1300" dirty="0"/>
+          </a:p>
+        </p:txBody>
+      </p:sp>
+      <p:sp>
+        <p:nvSpPr>
+          <p:cNvPr id="20" name="Text 18"/>
+          <p:cNvSpPr/>
+          <p:nvPr/>
+        </p:nvSpPr>
+        <p:spPr>
+          <a:xfrm>
+            <a:off x="1316736" y="4828032"/>
+            <a:ext cx="10149840" cy="548640"/>
+          </a:xfrm>
+          <a:prstGeom prst="rect">
+            <a:avLst/>
+          </a:prstGeom>
+          <a:noFill/>
+          <a:ln/>
+        </p:spPr>
+        <p:txBody>
+          <a:bodyPr wrap="square" lIns="0" tIns="0" rIns="0" bIns="0" rtlCol="0" anchor="ctr"/>
+          <a:lstStyle/>
+          <a:p>
+            <a:pPr indent="0" marL="0">
+              <a:lnSpc>
+                <a:spcPct val="115000"/>
+              </a:lnSpc>
+              <a:buNone/>
+            </a:pPr>
+            <a:r>
+              <a:rPr lang="en-US" sz="1100" dirty="0">
+                <a:solidFill>
+                  <a:srgbClr val="1F3B57"/>
+                </a:solidFill>
+                <a:latin typeface="Arial" pitchFamily="34" charset="0"/>
+                <a:ea typeface="Arial" pitchFamily="34" charset="-122"/>
+                <a:cs typeface="Arial" pitchFamily="34" charset="-120"/>
+              </a:rPr>
+              <a:t>CAPL은 "추론시 attention 수정만으로는 일시적 개선"이라고 선점 반론을 폈습니다.</a:t>
+            </a:r>
+            <a:endParaRPr lang="en-US" sz="1100" dirty="0"/>
+          </a:p>
+          <a:p>
+            <a:pPr indent="0" marL="0">
+              <a:lnSpc>
+                <a:spcPct val="115000"/>
+              </a:lnSpc>
+              <a:buNone/>
+            </a:pPr>
+            <a:r>
+              <a:rPr lang="en-US" sz="1100" dirty="0">
+                <a:solidFill>
+                  <a:srgbClr val="1F3B57"/>
+                </a:solidFill>
+                <a:latin typeface="Arial" pitchFamily="34" charset="0"/>
+                <a:ea typeface="Arial" pitchFamily="34" charset="-122"/>
+                <a:cs typeface="Arial" pitchFamily="34" charset="-120"/>
+              </a:rPr>
+              <a:t>BLINK·MUIRBench 같은 공개 벤치에서 재현해야 이 반론을 막습니다.</a:t>
+            </a:r>
+            <a:endParaRPr lang="en-US" sz="1100" dirty="0"/>
+          </a:p>
+        </p:txBody>
+      </p:sp>
+      <p:sp>
+        <p:nvSpPr>
+          <p:cNvPr id="21" name="Text 19"/>
+          <p:cNvSpPr/>
+          <p:nvPr/>
+        </p:nvSpPr>
+        <p:spPr>
+          <a:xfrm>
+            <a:off x="1316736" y="5413248"/>
+            <a:ext cx="10149840" cy="274320"/>
+          </a:xfrm>
+          <a:prstGeom prst="rect">
+            <a:avLst/>
+          </a:prstGeom>
+          <a:noFill/>
+          <a:ln/>
+        </p:spPr>
+        <p:txBody>
+          <a:bodyPr wrap="square" lIns="0" tIns="0" rIns="0" bIns="0" rtlCol="0" anchor="ctr"/>
+          <a:lstStyle/>
+          <a:p>
+            <a:pPr indent="0" marL="0">
+              <a:buNone/>
+            </a:pPr>
+            <a:r>
+              <a:rPr lang="en-US" sz="1100" b="1" dirty="0">
+                <a:solidFill>
+                  <a:srgbClr val="2E8B57"/>
+                </a:solidFill>
+                <a:latin typeface="Arial" pitchFamily="34" charset="0"/>
+                <a:ea typeface="Arial" pitchFamily="34" charset="-122"/>
+                <a:cs typeface="Arial" pitchFamily="34" charset="-120"/>
+              </a:rPr>
+              <a:t>대응: 다음 단계 1순위</a:t>
+            </a:r>
+            <a:endParaRPr lang="en-US" sz="1100" dirty="0"/>
+          </a:p>
+        </p:txBody>
+      </p:sp>
+      <p:sp>
+        <p:nvSpPr>
+          <p:cNvPr id="22" name="Shape 20"/>
+          <p:cNvSpPr/>
+          <p:nvPr/>
+        </p:nvSpPr>
+        <p:spPr>
+          <a:xfrm>
+            <a:off x="502920" y="6053328"/>
+            <a:ext cx="11201400" cy="548640"/>
+          </a:xfrm>
+          <a:prstGeom prst="roundRect">
+            <a:avLst>
+              <a:gd name="adj" fmla="val 13333"/>
+            </a:avLst>
+          </a:prstGeom>
+          <a:solidFill>
+            <a:srgbClr val="1F3B57"/>
+          </a:solidFill>
+          <a:ln/>
+        </p:spPr>
+      </p:sp>
+      <p:sp>
+        <p:nvSpPr>
+          <p:cNvPr id="23" name="Text 21"/>
+          <p:cNvSpPr/>
+          <p:nvPr/>
+        </p:nvSpPr>
+        <p:spPr>
+          <a:xfrm>
+            <a:off x="777240" y="6053328"/>
+            <a:ext cx="10744200" cy="548640"/>
+          </a:xfrm>
+          <a:prstGeom prst="rect">
+            <a:avLst/>
+          </a:prstGeom>
+          <a:noFill/>
+          <a:ln/>
+        </p:spPr>
+        <p:txBody>
+          <a:bodyPr wrap="square" lIns="0" tIns="0" rIns="0" bIns="0" rtlCol="0" anchor="ctr"/>
+          <a:lstStyle/>
+          <a:p>
+            <a:pPr indent="0" marL="0">
+              <a:buNone/>
+            </a:pPr>
+            <a:r>
+              <a:rPr lang="en-US" sz="1250" b="1" dirty="0">
+                <a:solidFill>
+                  <a:srgbClr val="FFFFFF"/>
+                </a:solidFill>
+                <a:latin typeface="Arial" pitchFamily="34" charset="0"/>
+                <a:ea typeface="Arial" pitchFamily="34" charset="-122"/>
+                <a:cs typeface="Arial" pitchFamily="34" charset="-120"/>
+              </a:rPr>
+              <a:t>→ 셋 다 알고 있고, 셋 다 측정으로 답할 수 있습니다</a:t>
+            </a:r>
+            <a:endParaRPr lang="en-US" sz="1250" dirty="0"/>
+          </a:p>
+        </p:txBody>
+      </p:sp>
+    </p:spTree>
+  </p:cSld>
+  <p:clrMapOvr>
+    <a:masterClrMapping/>
+  </p:clrMapOvr>
+</p:sld>
+</file>
+
+<file path=ppt/slides/slide11.xml><?xml version="1.0" encoding="utf-8"?>
+<p:sld xmlns:a="http://schemas.openxmlformats.org/drawingml/2006/main" xmlns:r="http://schemas.openxmlformats.org/officeDocument/2006/relationships" xmlns:p="http://schemas.openxmlformats.org/presentationml/2006/main">
+  <p:cSld name="Slide 11">
     <p:bg>
       <p:bgPr>
         <a:solidFill>
@@ -3394,7 +4325,7 @@
                 <a:ea typeface="Arial" pitchFamily="34" charset="-122"/>
                 <a:cs typeface="Arial" pitchFamily="34" charset="-120"/>
               </a:rPr>
-              <a:t>자원: GPU 1장 · 기존 코드·데이터 전부 재사용 · 지금까지 사전 등록 4건, 그중 2건은 실패로 기록했습니다</a:t>
+              <a:t>자원: GPU 1장 · 기존 코드·데이터 전부 재사용  ·  지금까지 사전 등록 5건, 그중 주 종점 실패 3건을 그대로 기록했습니다</a:t>
             </a:r>
             <a:endParaRPr lang="en-US" sz="1250" dirty="0"/>
           </a:p>
@@ -3411,6 +4342,1514 @@
 <file path=ppt/slides/slide2.xml><?xml version="1.0" encoding="utf-8"?>
 <p:sld xmlns:a="http://schemas.openxmlformats.org/drawingml/2006/main" xmlns:r="http://schemas.openxmlformats.org/officeDocument/2006/relationships" xmlns:p="http://schemas.openxmlformats.org/presentationml/2006/main">
   <p:cSld name="Slide 2">
+    <p:spTree>
+      <p:nvGrpSpPr>
+        <p:cNvPr id="1" name=""/>
+        <p:cNvGrpSpPr/>
+        <p:nvPr/>
+      </p:nvGrpSpPr>
+      <p:grpSpPr>
+        <a:xfrm>
+          <a:off x="0" y="0"/>
+          <a:ext cx="0" cy="0"/>
+          <a:chOff x="0" y="0"/>
+          <a:chExt cx="0" cy="0"/>
+        </a:xfrm>
+      </p:grpSpPr>
+      <p:sp>
+        <p:nvSpPr>
+          <p:cNvPr id="2" name="Text 0"/>
+          <p:cNvSpPr/>
+          <p:nvPr/>
+        </p:nvSpPr>
+        <p:spPr>
+          <a:xfrm>
+            <a:off x="502920" y="237744"/>
+            <a:ext cx="10515600" cy="274320"/>
+          </a:xfrm>
+          <a:prstGeom prst="rect">
+            <a:avLst/>
+          </a:prstGeom>
+          <a:noFill/>
+          <a:ln/>
+        </p:spPr>
+        <p:txBody>
+          <a:bodyPr wrap="square" lIns="0" tIns="0" rIns="0" bIns="0" rtlCol="0" anchor="ctr"/>
+          <a:lstStyle/>
+          <a:p>
+            <a:pPr indent="0" marL="0">
+              <a:buNone/>
+            </a:pPr>
+            <a:r>
+              <a:rPr lang="en-US" sz="1100" b="1" dirty="0">
+                <a:solidFill>
+                  <a:srgbClr val="1F77B4"/>
+                </a:solidFill>
+                <a:latin typeface="Arial" pitchFamily="34" charset="0"/>
+                <a:ea typeface="Arial" pitchFamily="34" charset="-122"/>
+                <a:cs typeface="Arial" pitchFamily="34" charset="-120"/>
+              </a:rPr>
+              <a:t>이 연구를 계속할 가치가 있는가</a:t>
+            </a:r>
+            <a:endParaRPr lang="en-US" sz="1100" dirty="0"/>
+          </a:p>
+        </p:txBody>
+      </p:sp>
+      <p:sp>
+        <p:nvSpPr>
+          <p:cNvPr id="3" name="Text 1"/>
+          <p:cNvSpPr/>
+          <p:nvPr/>
+        </p:nvSpPr>
+        <p:spPr>
+          <a:xfrm>
+            <a:off x="502920" y="493776"/>
+            <a:ext cx="11155680" cy="658368"/>
+          </a:xfrm>
+          <a:prstGeom prst="rect">
+            <a:avLst/>
+          </a:prstGeom>
+          <a:noFill/>
+          <a:ln/>
+        </p:spPr>
+        <p:txBody>
+          <a:bodyPr wrap="square" lIns="0" tIns="0" rIns="0" bIns="0" rtlCol="0" anchor="ctr"/>
+          <a:lstStyle/>
+          <a:p>
+            <a:pPr indent="0" marL="0">
+              <a:buNone/>
+            </a:pPr>
+            <a:r>
+              <a:rPr lang="en-US" sz="2100" b="1" dirty="0">
+                <a:solidFill>
+                  <a:srgbClr val="1F3B57"/>
+                </a:solidFill>
+                <a:latin typeface="Arial" pitchFamily="34" charset="0"/>
+                <a:ea typeface="Arial" pitchFamily="34" charset="-122"/>
+                <a:cs typeface="Arial" pitchFamily="34" charset="-120"/>
+              </a:rPr>
+              <a:t>기존 연구가 정반대 처방을 내놓은 지점 — 그 모순을 우리가 풀었습니다</a:t>
+            </a:r>
+            <a:endParaRPr lang="en-US" sz="2100" dirty="0"/>
+          </a:p>
+        </p:txBody>
+      </p:sp>
+      <p:sp>
+        <p:nvSpPr>
+          <p:cNvPr id="4" name="Shape 2"/>
+          <p:cNvSpPr/>
+          <p:nvPr/>
+        </p:nvSpPr>
+        <p:spPr>
+          <a:xfrm>
+            <a:off x="502920" y="1207008"/>
+            <a:ext cx="11201400" cy="932688"/>
+          </a:xfrm>
+          <a:prstGeom prst="roundRect">
+            <a:avLst>
+              <a:gd name="adj" fmla="val 7843"/>
+            </a:avLst>
+          </a:prstGeom>
+          <a:solidFill>
+            <a:srgbClr val="1F3B57"/>
+          </a:solidFill>
+          <a:ln/>
+        </p:spPr>
+      </p:sp>
+      <p:sp>
+        <p:nvSpPr>
+          <p:cNvPr id="5" name="Text 3"/>
+          <p:cNvSpPr/>
+          <p:nvPr/>
+        </p:nvSpPr>
+        <p:spPr>
+          <a:xfrm>
+            <a:off x="822960" y="1298448"/>
+            <a:ext cx="10607040" cy="777240"/>
+          </a:xfrm>
+          <a:prstGeom prst="rect">
+            <a:avLst/>
+          </a:prstGeom>
+          <a:noFill/>
+          <a:ln/>
+        </p:spPr>
+        <p:txBody>
+          <a:bodyPr wrap="square" lIns="0" tIns="0" rIns="0" bIns="0" rtlCol="0" anchor="ctr"/>
+          <a:lstStyle/>
+          <a:p>
+            <a:pPr indent="0" marL="0">
+              <a:spcAft>
+                <a:spcPts val="200"/>
+              </a:spcAft>
+              <a:buNone/>
+            </a:pPr>
+            <a:r>
+              <a:rPr lang="en-US" sz="1100" b="1" dirty="0">
+                <a:solidFill>
+                  <a:srgbClr val="9FB8CE"/>
+                </a:solidFill>
+                <a:latin typeface="Arial" pitchFamily="34" charset="0"/>
+                <a:ea typeface="Arial" pitchFamily="34" charset="-122"/>
+                <a:cs typeface="Arial" pitchFamily="34" charset="-120"/>
+              </a:rPr>
+              <a:t>연구 질문   </a:t>
+            </a:r>
+            <a:pPr indent="0" marL="0">
+              <a:spcAft>
+                <a:spcPts val="200"/>
+              </a:spcAft>
+              <a:buNone/>
+            </a:pPr>
+            <a:r>
+              <a:rPr lang="en-US" sz="1400" b="1" dirty="0">
+                <a:solidFill>
+                  <a:srgbClr val="FFFFFF"/>
+                </a:solidFill>
+                <a:latin typeface="Arial" pitchFamily="34" charset="0"/>
+                <a:ea typeface="Arial" pitchFamily="34" charset="-122"/>
+                <a:cs typeface="Arial" pitchFamily="34" charset="-120"/>
+              </a:rPr>
+              <a:t>멀티이미지 입력에서 무관한 이미지가 모델을 망칠 때,</a:t>
+            </a:r>
+            <a:endParaRPr lang="en-US" sz="1100" dirty="0"/>
+          </a:p>
+          <a:p>
+            <a:pPr indent="0" marL="0">
+              <a:spcAft>
+                <a:spcPts val="200"/>
+              </a:spcAft>
+              <a:buNone/>
+            </a:pPr>
+            <a:r>
+              <a:rPr lang="en-US" sz="1400" b="1" dirty="0">
+                <a:solidFill>
+                  <a:srgbClr val="FFFFFF"/>
+                </a:solidFill>
+                <a:latin typeface="Arial" pitchFamily="34" charset="0"/>
+                <a:ea typeface="Arial" pitchFamily="34" charset="-122"/>
+                <a:cs typeface="Arial" pitchFamily="34" charset="-120"/>
+              </a:rPr>
+              <a:t>그 해악은 어느 attention 경로로 흐르며, 어디를 끊어야 회복되는가?</a:t>
+            </a:r>
+            <a:endParaRPr lang="en-US" sz="1100" dirty="0"/>
+          </a:p>
+        </p:txBody>
+      </p:sp>
+      <p:sp>
+        <p:nvSpPr>
+          <p:cNvPr id="6" name="Shape 4"/>
+          <p:cNvSpPr/>
+          <p:nvPr/>
+        </p:nvSpPr>
+        <p:spPr>
+          <a:xfrm>
+            <a:off x="502920" y="2286000"/>
+            <a:ext cx="5532120" cy="1481328"/>
+          </a:xfrm>
+          <a:prstGeom prst="roundRect">
+            <a:avLst>
+              <a:gd name="adj" fmla="val 4938"/>
+            </a:avLst>
+          </a:prstGeom>
+          <a:solidFill>
+            <a:srgbClr val="FBEAEA"/>
+          </a:solidFill>
+          <a:ln w="15875">
+            <a:solidFill>
+              <a:srgbClr val="D62728"/>
+            </a:solidFill>
+            <a:prstDash val="solid"/>
+          </a:ln>
+        </p:spPr>
+      </p:sp>
+      <p:sp>
+        <p:nvSpPr>
+          <p:cNvPr id="7" name="Text 5"/>
+          <p:cNvSpPr/>
+          <p:nvPr/>
+        </p:nvSpPr>
+        <p:spPr>
+          <a:xfrm>
+            <a:off x="713232" y="2395728"/>
+            <a:ext cx="5120640" cy="256032"/>
+          </a:xfrm>
+          <a:prstGeom prst="rect">
+            <a:avLst/>
+          </a:prstGeom>
+          <a:noFill/>
+          <a:ln/>
+        </p:spPr>
+        <p:txBody>
+          <a:bodyPr wrap="square" lIns="0" tIns="0" rIns="0" bIns="0" rtlCol="0" anchor="ctr"/>
+          <a:lstStyle/>
+          <a:p>
+            <a:pPr indent="0" marL="0">
+              <a:buNone/>
+            </a:pPr>
+            <a:r>
+              <a:rPr lang="en-US" sz="1250" b="1" dirty="0">
+                <a:solidFill>
+                  <a:srgbClr val="D62728"/>
+                </a:solidFill>
+                <a:latin typeface="Arial" pitchFamily="34" charset="0"/>
+                <a:ea typeface="Arial" pitchFamily="34" charset="-122"/>
+                <a:cs typeface="Arial" pitchFamily="34" charset="-120"/>
+              </a:rPr>
+              <a:t>문제 상황 — 문헌이 갈려 있다</a:t>
+            </a:r>
+            <a:endParaRPr lang="en-US" sz="1250" dirty="0"/>
+          </a:p>
+        </p:txBody>
+      </p:sp>
+      <p:sp>
+        <p:nvSpPr>
+          <p:cNvPr id="8" name="Text 6"/>
+          <p:cNvSpPr/>
+          <p:nvPr/>
+        </p:nvSpPr>
+        <p:spPr>
+          <a:xfrm>
+            <a:off x="713232" y="2688336"/>
+            <a:ext cx="5120640" cy="1005840"/>
+          </a:xfrm>
+          <a:prstGeom prst="rect">
+            <a:avLst/>
+          </a:prstGeom>
+          <a:noFill/>
+          <a:ln/>
+        </p:spPr>
+        <p:txBody>
+          <a:bodyPr wrap="square" lIns="0" tIns="0" rIns="0" bIns="0" rtlCol="0" anchor="ctr"/>
+          <a:lstStyle/>
+          <a:p>
+            <a:pPr indent="0" marL="0">
+              <a:lnSpc>
+                <a:spcPct val="115000"/>
+              </a:lnSpc>
+              <a:buNone/>
+            </a:pPr>
+            <a:r>
+              <a:rPr lang="en-US" sz="1050" dirty="0">
+                <a:solidFill>
+                  <a:srgbClr val="1F3B57"/>
+                </a:solidFill>
+                <a:latin typeface="Arial" pitchFamily="34" charset="0"/>
+                <a:ea typeface="Arial" pitchFamily="34" charset="-122"/>
+                <a:cs typeface="Arial" pitchFamily="34" charset="-120"/>
+              </a:rPr>
+              <a:t>CAPL · SoFA :  "cross-image 정보가 부족하다" → attention을 연다</a:t>
+            </a:r>
+            <a:endParaRPr lang="en-US" sz="1050" dirty="0"/>
+          </a:p>
+          <a:p>
+            <a:pPr indent="0" marL="0">
+              <a:lnSpc>
+                <a:spcPct val="115000"/>
+              </a:lnSpc>
+              <a:buNone/>
+            </a:pPr>
+            <a:r>
+              <a:rPr lang="en-US" sz="1050" dirty="0">
+                <a:solidFill>
+                  <a:srgbClr val="1F3B57"/>
+                </a:solidFill>
+                <a:latin typeface="Arial" pitchFamily="34" charset="0"/>
+                <a:ea typeface="Arial" pitchFamily="34" charset="-122"/>
+                <a:cs typeface="Arial" pitchFamily="34" charset="-120"/>
+              </a:rPr>
+              <a:t>MIMIC :  "cross-image가 오염시킨다" → 균일하게 막는다</a:t>
+            </a:r>
+            <a:endParaRPr lang="en-US" sz="1050" dirty="0"/>
+          </a:p>
+          <a:p>
+            <a:pPr indent="0" marL="0">
+              <a:lnSpc>
+                <a:spcPct val="115000"/>
+              </a:lnSpc>
+              <a:buNone/>
+            </a:pPr>
+            <a:endParaRPr lang="en-US" sz="1050" dirty="0"/>
+          </a:p>
+          <a:p>
+            <a:pPr indent="0" marL="0">
+              <a:lnSpc>
+                <a:spcPct val="115000"/>
+              </a:lnSpc>
+              <a:buNone/>
+            </a:pPr>
+            <a:r>
+              <a:rPr lang="en-US" sz="1050" dirty="0">
+                <a:solidFill>
+                  <a:srgbClr val="1F3B57"/>
+                </a:solidFill>
+                <a:latin typeface="Arial" pitchFamily="34" charset="0"/>
+                <a:ea typeface="Arial" pitchFamily="34" charset="-122"/>
+                <a:cs typeface="Arial" pitchFamily="34" charset="-120"/>
+              </a:rPr>
+              <a:t>정반대 처방인데 양쪽 다 개선을 보고합니다. 아무도 이유를 설명하지 못했습니다.</a:t>
+            </a:r>
+            <a:endParaRPr lang="en-US" sz="1050" dirty="0"/>
+          </a:p>
+        </p:txBody>
+      </p:sp>
+      <p:sp>
+        <p:nvSpPr>
+          <p:cNvPr id="9" name="Shape 7"/>
+          <p:cNvSpPr/>
+          <p:nvPr/>
+        </p:nvSpPr>
+        <p:spPr>
+          <a:xfrm>
+            <a:off x="6199632" y="2286000"/>
+            <a:ext cx="5504688" cy="1481328"/>
+          </a:xfrm>
+          <a:prstGeom prst="roundRect">
+            <a:avLst>
+              <a:gd name="adj" fmla="val 4938"/>
+            </a:avLst>
+          </a:prstGeom>
+          <a:solidFill>
+            <a:srgbClr val="E9F4EE"/>
+          </a:solidFill>
+          <a:ln w="15875">
+            <a:solidFill>
+              <a:srgbClr val="2E8B57"/>
+            </a:solidFill>
+            <a:prstDash val="solid"/>
+          </a:ln>
+        </p:spPr>
+      </p:sp>
+      <p:sp>
+        <p:nvSpPr>
+          <p:cNvPr id="10" name="Text 8"/>
+          <p:cNvSpPr/>
+          <p:nvPr/>
+        </p:nvSpPr>
+        <p:spPr>
+          <a:xfrm>
+            <a:off x="6409944" y="2395728"/>
+            <a:ext cx="5120640" cy="256032"/>
+          </a:xfrm>
+          <a:prstGeom prst="rect">
+            <a:avLst/>
+          </a:prstGeom>
+          <a:noFill/>
+          <a:ln/>
+        </p:spPr>
+        <p:txBody>
+          <a:bodyPr wrap="square" lIns="0" tIns="0" rIns="0" bIns="0" rtlCol="0" anchor="ctr"/>
+          <a:lstStyle/>
+          <a:p>
+            <a:pPr indent="0" marL="0">
+              <a:buNone/>
+            </a:pPr>
+            <a:r>
+              <a:rPr lang="en-US" sz="1250" b="1" dirty="0">
+                <a:solidFill>
+                  <a:srgbClr val="2E8B57"/>
+                </a:solidFill>
+                <a:latin typeface="Arial" pitchFamily="34" charset="0"/>
+                <a:ea typeface="Arial" pitchFamily="34" charset="-122"/>
+                <a:cs typeface="Arial" pitchFamily="34" charset="-120"/>
+              </a:rPr>
+              <a:t>우리 답 — 경로를 나누면 둘 다 맞다</a:t>
+            </a:r>
+            <a:endParaRPr lang="en-US" sz="1250" dirty="0"/>
+          </a:p>
+        </p:txBody>
+      </p:sp>
+      <p:sp>
+        <p:nvSpPr>
+          <p:cNvPr id="11" name="Text 9"/>
+          <p:cNvSpPr/>
+          <p:nvPr/>
+        </p:nvSpPr>
+        <p:spPr>
+          <a:xfrm>
+            <a:off x="6409944" y="2688336"/>
+            <a:ext cx="5120640" cy="1005840"/>
+          </a:xfrm>
+          <a:prstGeom prst="rect">
+            <a:avLst/>
+          </a:prstGeom>
+          <a:noFill/>
+          <a:ln/>
+        </p:spPr>
+        <p:txBody>
+          <a:bodyPr wrap="square" lIns="0" tIns="0" rIns="0" bIns="0" rtlCol="0" anchor="ctr"/>
+          <a:lstStyle/>
+          <a:p>
+            <a:pPr indent="0" marL="0">
+              <a:lnSpc>
+                <a:spcPct val="115000"/>
+              </a:lnSpc>
+              <a:buNone/>
+            </a:pPr>
+            <a:r>
+              <a:rPr lang="en-US" sz="1050" dirty="0">
+                <a:solidFill>
+                  <a:srgbClr val="1F3B57"/>
+                </a:solidFill>
+                <a:latin typeface="Arial" pitchFamily="34" charset="0"/>
+                <a:ea typeface="Arial" pitchFamily="34" charset="-122"/>
+                <a:cs typeface="Arial" pitchFamily="34" charset="-120"/>
+              </a:rPr>
+              <a:t>이미지 → 이미지 (혼합) :  도움이 된다. 끊으면 −0.23 ~ −0.43</a:t>
+            </a:r>
+            <a:endParaRPr lang="en-US" sz="1050" dirty="0"/>
+          </a:p>
+          <a:p>
+            <a:pPr indent="0" marL="0">
+              <a:lnSpc>
+                <a:spcPct val="115000"/>
+              </a:lnSpc>
+              <a:buNone/>
+            </a:pPr>
+            <a:r>
+              <a:rPr lang="en-US" sz="1050" dirty="0">
+                <a:solidFill>
+                  <a:srgbClr val="1F3B57"/>
+                </a:solidFill>
+                <a:latin typeface="Arial" pitchFamily="34" charset="0"/>
+                <a:ea typeface="Arial" pitchFamily="34" charset="-122"/>
+                <a:cs typeface="Arial" pitchFamily="34" charset="-120"/>
+              </a:rPr>
+              <a:t>질문 → 이미지 (읽기) :  해악이 전부 여기. 끊으면 회복</a:t>
+            </a:r>
+            <a:endParaRPr lang="en-US" sz="1050" dirty="0"/>
+          </a:p>
+          <a:p>
+            <a:pPr indent="0" marL="0">
+              <a:lnSpc>
+                <a:spcPct val="115000"/>
+              </a:lnSpc>
+              <a:buNone/>
+            </a:pPr>
+            <a:endParaRPr lang="en-US" sz="1050" dirty="0"/>
+          </a:p>
+          <a:p>
+            <a:pPr indent="0" marL="0">
+              <a:lnSpc>
+                <a:spcPct val="115000"/>
+              </a:lnSpc>
+              <a:buNone/>
+            </a:pPr>
+            <a:r>
+              <a:rPr lang="en-US" sz="1050" dirty="0">
+                <a:solidFill>
+                  <a:srgbClr val="1F3B57"/>
+                </a:solidFill>
+                <a:latin typeface="Arial" pitchFamily="34" charset="0"/>
+                <a:ea typeface="Arial" pitchFamily="34" charset="-122"/>
+                <a:cs typeface="Arial" pitchFamily="34" charset="-120"/>
+              </a:rPr>
+              <a:t>→ 최적 개입은 '제거'도 '개방'도 아닌 제3의 처방입니다</a:t>
+            </a:r>
+            <a:endParaRPr lang="en-US" sz="1050" dirty="0"/>
+          </a:p>
+        </p:txBody>
+      </p:sp>
+      <p:sp>
+        <p:nvSpPr>
+          <p:cNvPr id="12" name="Text 10"/>
+          <p:cNvSpPr/>
+          <p:nvPr/>
+        </p:nvSpPr>
+        <p:spPr>
+          <a:xfrm>
+            <a:off x="502920" y="3913632"/>
+            <a:ext cx="11201400" cy="256032"/>
+          </a:xfrm>
+          <a:prstGeom prst="rect">
+            <a:avLst/>
+          </a:prstGeom>
+          <a:noFill/>
+          <a:ln/>
+        </p:spPr>
+        <p:txBody>
+          <a:bodyPr wrap="square" lIns="0" tIns="0" rIns="0" bIns="0" rtlCol="0" anchor="ctr"/>
+          <a:lstStyle/>
+          <a:p>
+            <a:pPr indent="0" marL="0">
+              <a:buNone/>
+            </a:pPr>
+            <a:r>
+              <a:rPr lang="en-US" sz="1250" b="1" dirty="0">
+                <a:solidFill>
+                  <a:srgbClr val="1F3B57"/>
+                </a:solidFill>
+                <a:latin typeface="Arial" pitchFamily="34" charset="0"/>
+                <a:ea typeface="Arial" pitchFamily="34" charset="-122"/>
+                <a:cs typeface="Arial" pitchFamily="34" charset="-120"/>
+              </a:rPr>
+              <a:t>기여 5가지 — 전부 실측 (n=300, 사전 등록 후 실행)</a:t>
+            </a:r>
+            <a:endParaRPr lang="en-US" sz="1250" dirty="0"/>
+          </a:p>
+        </p:txBody>
+      </p:sp>
+      <p:sp>
+        <p:nvSpPr>
+          <p:cNvPr id="13" name="Shape 11"/>
+          <p:cNvSpPr/>
+          <p:nvPr/>
+        </p:nvSpPr>
+        <p:spPr>
+          <a:xfrm>
+            <a:off x="502920" y="4224528"/>
+            <a:ext cx="11201400" cy="338328"/>
+          </a:xfrm>
+          <a:prstGeom prst="roundRect">
+            <a:avLst>
+              <a:gd name="adj" fmla="val 13514"/>
+            </a:avLst>
+          </a:prstGeom>
+          <a:solidFill>
+            <a:srgbClr val="F3F4F6"/>
+          </a:solidFill>
+          <a:ln/>
+        </p:spPr>
+      </p:sp>
+      <p:sp>
+        <p:nvSpPr>
+          <p:cNvPr id="14" name="Text 12"/>
+          <p:cNvSpPr/>
+          <p:nvPr/>
+        </p:nvSpPr>
+        <p:spPr>
+          <a:xfrm>
+            <a:off x="658368" y="4224528"/>
+            <a:ext cx="457200" cy="338328"/>
+          </a:xfrm>
+          <a:prstGeom prst="rect">
+            <a:avLst/>
+          </a:prstGeom>
+          <a:noFill/>
+          <a:ln/>
+        </p:spPr>
+        <p:txBody>
+          <a:bodyPr wrap="square" lIns="0" tIns="0" rIns="0" bIns="0" rtlCol="0" anchor="ctr"/>
+          <a:lstStyle/>
+          <a:p>
+            <a:pPr indent="0" marL="0">
+              <a:buNone/>
+            </a:pPr>
+            <a:r>
+              <a:rPr lang="en-US" sz="1100" b="1" dirty="0">
+                <a:solidFill>
+                  <a:srgbClr val="1F77B4"/>
+                </a:solidFill>
+                <a:latin typeface="Arial" pitchFamily="34" charset="0"/>
+                <a:ea typeface="Arial" pitchFamily="34" charset="-122"/>
+                <a:cs typeface="Arial" pitchFamily="34" charset="-120"/>
+              </a:rPr>
+              <a:t>C1</a:t>
+            </a:r>
+            <a:endParaRPr lang="en-US" sz="1100" dirty="0"/>
+          </a:p>
+        </p:txBody>
+      </p:sp>
+      <p:sp>
+        <p:nvSpPr>
+          <p:cNvPr id="15" name="Text 13"/>
+          <p:cNvSpPr/>
+          <p:nvPr/>
+        </p:nvSpPr>
+        <p:spPr>
+          <a:xfrm>
+            <a:off x="1188720" y="4224528"/>
+            <a:ext cx="2286000" cy="338328"/>
+          </a:xfrm>
+          <a:prstGeom prst="rect">
+            <a:avLst/>
+          </a:prstGeom>
+          <a:noFill/>
+          <a:ln/>
+        </p:spPr>
+        <p:txBody>
+          <a:bodyPr wrap="square" lIns="0" tIns="0" rIns="0" bIns="0" rtlCol="0" anchor="ctr"/>
+          <a:lstStyle/>
+          <a:p>
+            <a:pPr indent="0" marL="0">
+              <a:buNone/>
+            </a:pPr>
+            <a:r>
+              <a:rPr lang="en-US" sz="1100" b="1" dirty="0">
+                <a:solidFill>
+                  <a:srgbClr val="1F3B57"/>
+                </a:solidFill>
+                <a:latin typeface="Arial" pitchFamily="34" charset="0"/>
+                <a:ea typeface="Arial" pitchFamily="34" charset="-122"/>
+                <a:cs typeface="Arial" pitchFamily="34" charset="-120"/>
+              </a:rPr>
+              <a:t>경로 분해</a:t>
+            </a:r>
+            <a:endParaRPr lang="en-US" sz="1100" dirty="0"/>
+          </a:p>
+        </p:txBody>
+      </p:sp>
+      <p:sp>
+        <p:nvSpPr>
+          <p:cNvPr id="16" name="Text 14"/>
+          <p:cNvSpPr/>
+          <p:nvPr/>
+        </p:nvSpPr>
+        <p:spPr>
+          <a:xfrm>
+            <a:off x="3566160" y="4224528"/>
+            <a:ext cx="3931920" cy="338328"/>
+          </a:xfrm>
+          <a:prstGeom prst="rect">
+            <a:avLst/>
+          </a:prstGeom>
+          <a:noFill/>
+          <a:ln/>
+        </p:spPr>
+        <p:txBody>
+          <a:bodyPr wrap="square" lIns="0" tIns="0" rIns="0" bIns="0" rtlCol="0" anchor="ctr"/>
+          <a:lstStyle/>
+          <a:p>
+            <a:pPr indent="0" marL="0">
+              <a:buNone/>
+            </a:pPr>
+            <a:r>
+              <a:rPr lang="en-US" sz="1050" dirty="0">
+                <a:solidFill>
+                  <a:srgbClr val="1F3B57"/>
+                </a:solidFill>
+                <a:latin typeface="Arial" pitchFamily="34" charset="0"/>
+                <a:ea typeface="Arial" pitchFamily="34" charset="-122"/>
+                <a:cs typeface="Arial" pitchFamily="34" charset="-120"/>
+              </a:rPr>
+              <a:t>해악은 읽기 경로에만. 혼합은 보호막</a:t>
+            </a:r>
+            <a:endParaRPr lang="en-US" sz="1050" dirty="0"/>
+          </a:p>
+        </p:txBody>
+      </p:sp>
+      <p:sp>
+        <p:nvSpPr>
+          <p:cNvPr id="17" name="Text 15"/>
+          <p:cNvSpPr/>
+          <p:nvPr/>
+        </p:nvSpPr>
+        <p:spPr>
+          <a:xfrm>
+            <a:off x="7589520" y="4224528"/>
+            <a:ext cx="4023360" cy="338328"/>
+          </a:xfrm>
+          <a:prstGeom prst="rect">
+            <a:avLst/>
+          </a:prstGeom>
+          <a:noFill/>
+          <a:ln/>
+        </p:spPr>
+        <p:txBody>
+          <a:bodyPr wrap="square" lIns="0" tIns="0" rIns="0" bIns="0" rtlCol="0" anchor="ctr"/>
+          <a:lstStyle/>
+          <a:p>
+            <a:pPr indent="0" marL="0">
+              <a:buNone/>
+            </a:pPr>
+            <a:r>
+              <a:rPr lang="en-US" sz="1000" dirty="0">
+                <a:solidFill>
+                  <a:srgbClr val="6B7280"/>
+                </a:solidFill>
+                <a:latin typeface="Arial" pitchFamily="34" charset="0"/>
+                <a:ea typeface="Arial" pitchFamily="34" charset="-122"/>
+                <a:cs typeface="Arial" pitchFamily="34" charset="-120"/>
+              </a:rPr>
+              <a:t>2배치 × 2모델 = 4조건 전부 일관</a:t>
+            </a:r>
+            <a:endParaRPr lang="en-US" sz="1000" dirty="0"/>
+          </a:p>
+        </p:txBody>
+      </p:sp>
+      <p:sp>
+        <p:nvSpPr>
+          <p:cNvPr id="18" name="Shape 16"/>
+          <p:cNvSpPr/>
+          <p:nvPr/>
+        </p:nvSpPr>
+        <p:spPr>
+          <a:xfrm>
+            <a:off x="502920" y="4599432"/>
+            <a:ext cx="11201400" cy="338328"/>
+          </a:xfrm>
+          <a:prstGeom prst="roundRect">
+            <a:avLst>
+              <a:gd name="adj" fmla="val 13514"/>
+            </a:avLst>
+          </a:prstGeom>
+          <a:solidFill>
+            <a:srgbClr val="EFF4F9"/>
+          </a:solidFill>
+          <a:ln/>
+        </p:spPr>
+      </p:sp>
+      <p:sp>
+        <p:nvSpPr>
+          <p:cNvPr id="19" name="Text 17"/>
+          <p:cNvSpPr/>
+          <p:nvPr/>
+        </p:nvSpPr>
+        <p:spPr>
+          <a:xfrm>
+            <a:off x="658368" y="4599432"/>
+            <a:ext cx="457200" cy="338328"/>
+          </a:xfrm>
+          <a:prstGeom prst="rect">
+            <a:avLst/>
+          </a:prstGeom>
+          <a:noFill/>
+          <a:ln/>
+        </p:spPr>
+        <p:txBody>
+          <a:bodyPr wrap="square" lIns="0" tIns="0" rIns="0" bIns="0" rtlCol="0" anchor="ctr"/>
+          <a:lstStyle/>
+          <a:p>
+            <a:pPr indent="0" marL="0">
+              <a:buNone/>
+            </a:pPr>
+            <a:r>
+              <a:rPr lang="en-US" sz="1100" b="1" dirty="0">
+                <a:solidFill>
+                  <a:srgbClr val="1F77B4"/>
+                </a:solidFill>
+                <a:latin typeface="Arial" pitchFamily="34" charset="0"/>
+                <a:ea typeface="Arial" pitchFamily="34" charset="-122"/>
+                <a:cs typeface="Arial" pitchFamily="34" charset="-120"/>
+              </a:rPr>
+              <a:t>C2</a:t>
+            </a:r>
+            <a:endParaRPr lang="en-US" sz="1100" dirty="0"/>
+          </a:p>
+        </p:txBody>
+      </p:sp>
+      <p:sp>
+        <p:nvSpPr>
+          <p:cNvPr id="20" name="Text 18"/>
+          <p:cNvSpPr/>
+          <p:nvPr/>
+        </p:nvSpPr>
+        <p:spPr>
+          <a:xfrm>
+            <a:off x="1188720" y="4599432"/>
+            <a:ext cx="2286000" cy="338328"/>
+          </a:xfrm>
+          <a:prstGeom prst="rect">
+            <a:avLst/>
+          </a:prstGeom>
+          <a:noFill/>
+          <a:ln/>
+        </p:spPr>
+        <p:txBody>
+          <a:bodyPr wrap="square" lIns="0" tIns="0" rIns="0" bIns="0" rtlCol="0" anchor="ctr"/>
+          <a:lstStyle/>
+          <a:p>
+            <a:pPr indent="0" marL="0">
+              <a:buNone/>
+            </a:pPr>
+            <a:r>
+              <a:rPr lang="en-US" sz="1100" b="1" dirty="0">
+                <a:solidFill>
+                  <a:srgbClr val="1F3B57"/>
+                </a:solidFill>
+                <a:latin typeface="Arial" pitchFamily="34" charset="0"/>
+                <a:ea typeface="Arial" pitchFamily="34" charset="-122"/>
+                <a:cs typeface="Arial" pitchFamily="34" charset="-120"/>
+              </a:rPr>
+              <a:t>경로 선택적 개입</a:t>
+            </a:r>
+            <a:endParaRPr lang="en-US" sz="1100" dirty="0"/>
+          </a:p>
+        </p:txBody>
+      </p:sp>
+      <p:sp>
+        <p:nvSpPr>
+          <p:cNvPr id="21" name="Text 19"/>
+          <p:cNvSpPr/>
+          <p:nvPr/>
+        </p:nvSpPr>
+        <p:spPr>
+          <a:xfrm>
+            <a:off x="3566160" y="4599432"/>
+            <a:ext cx="3931920" cy="338328"/>
+          </a:xfrm>
+          <a:prstGeom prst="rect">
+            <a:avLst/>
+          </a:prstGeom>
+          <a:noFill/>
+          <a:ln/>
+        </p:spPr>
+        <p:txBody>
+          <a:bodyPr wrap="square" lIns="0" tIns="0" rIns="0" bIns="0" rtlCol="0" anchor="ctr"/>
+          <a:lstStyle/>
+          <a:p>
+            <a:pPr indent="0" marL="0">
+              <a:buNone/>
+            </a:pPr>
+            <a:r>
+              <a:rPr lang="en-US" sz="1050" dirty="0">
+                <a:solidFill>
+                  <a:srgbClr val="1F3B57"/>
+                </a:solidFill>
+                <a:latin typeface="Arial" pitchFamily="34" charset="0"/>
+                <a:ea typeface="Arial" pitchFamily="34" charset="-122"/>
+                <a:cs typeface="Arial" pitchFamily="34" charset="-120"/>
+              </a:rPr>
+              <a:t>읽기만 끊는 것 &gt; 통째로 지우기</a:t>
+            </a:r>
+            <a:endParaRPr lang="en-US" sz="1050" dirty="0"/>
+          </a:p>
+        </p:txBody>
+      </p:sp>
+      <p:sp>
+        <p:nvSpPr>
+          <p:cNvPr id="22" name="Text 20"/>
+          <p:cNvSpPr/>
+          <p:nvPr/>
+        </p:nvSpPr>
+        <p:spPr>
+          <a:xfrm>
+            <a:off x="7589520" y="4599432"/>
+            <a:ext cx="4023360" cy="338328"/>
+          </a:xfrm>
+          <a:prstGeom prst="rect">
+            <a:avLst/>
+          </a:prstGeom>
+          <a:noFill/>
+          <a:ln/>
+        </p:spPr>
+        <p:txBody>
+          <a:bodyPr wrap="square" lIns="0" tIns="0" rIns="0" bIns="0" rtlCol="0" anchor="ctr"/>
+          <a:lstStyle/>
+          <a:p>
+            <a:pPr indent="0" marL="0">
+              <a:buNone/>
+            </a:pPr>
+            <a:r>
+              <a:rPr lang="en-US" sz="1000" dirty="0">
+                <a:solidFill>
+                  <a:srgbClr val="6B7280"/>
+                </a:solidFill>
+                <a:latin typeface="Arial" pitchFamily="34" charset="0"/>
+                <a:ea typeface="Arial" pitchFamily="34" charset="-122"/>
+                <a:cs typeface="Arial" pitchFamily="34" charset="-120"/>
+              </a:rPr>
+              <a:t>+0.018  CI [+.007,+.031]  회복 121%</a:t>
+            </a:r>
+            <a:endParaRPr lang="en-US" sz="1000" dirty="0"/>
+          </a:p>
+        </p:txBody>
+      </p:sp>
+      <p:sp>
+        <p:nvSpPr>
+          <p:cNvPr id="23" name="Shape 21"/>
+          <p:cNvSpPr/>
+          <p:nvPr/>
+        </p:nvSpPr>
+        <p:spPr>
+          <a:xfrm>
+            <a:off x="502920" y="4974336"/>
+            <a:ext cx="11201400" cy="338328"/>
+          </a:xfrm>
+          <a:prstGeom prst="roundRect">
+            <a:avLst>
+              <a:gd name="adj" fmla="val 13514"/>
+            </a:avLst>
+          </a:prstGeom>
+          <a:solidFill>
+            <a:srgbClr val="F3F4F6"/>
+          </a:solidFill>
+          <a:ln/>
+        </p:spPr>
+      </p:sp>
+      <p:sp>
+        <p:nvSpPr>
+          <p:cNvPr id="24" name="Text 22"/>
+          <p:cNvSpPr/>
+          <p:nvPr/>
+        </p:nvSpPr>
+        <p:spPr>
+          <a:xfrm>
+            <a:off x="658368" y="4974336"/>
+            <a:ext cx="457200" cy="338328"/>
+          </a:xfrm>
+          <a:prstGeom prst="rect">
+            <a:avLst/>
+          </a:prstGeom>
+          <a:noFill/>
+          <a:ln/>
+        </p:spPr>
+        <p:txBody>
+          <a:bodyPr wrap="square" lIns="0" tIns="0" rIns="0" bIns="0" rtlCol="0" anchor="ctr"/>
+          <a:lstStyle/>
+          <a:p>
+            <a:pPr indent="0" marL="0">
+              <a:buNone/>
+            </a:pPr>
+            <a:r>
+              <a:rPr lang="en-US" sz="1100" b="1" dirty="0">
+                <a:solidFill>
+                  <a:srgbClr val="1F77B4"/>
+                </a:solidFill>
+                <a:latin typeface="Arial" pitchFamily="34" charset="0"/>
+                <a:ea typeface="Arial" pitchFamily="34" charset="-122"/>
+                <a:cs typeface="Arial" pitchFamily="34" charset="-120"/>
+              </a:rPr>
+              <a:t>C3</a:t>
+            </a:r>
+            <a:endParaRPr lang="en-US" sz="1100" dirty="0"/>
+          </a:p>
+        </p:txBody>
+      </p:sp>
+      <p:sp>
+        <p:nvSpPr>
+          <p:cNvPr id="25" name="Text 23"/>
+          <p:cNvSpPr/>
+          <p:nvPr/>
+        </p:nvSpPr>
+        <p:spPr>
+          <a:xfrm>
+            <a:off x="1188720" y="4974336"/>
+            <a:ext cx="2286000" cy="338328"/>
+          </a:xfrm>
+          <a:prstGeom prst="rect">
+            <a:avLst/>
+          </a:prstGeom>
+          <a:noFill/>
+          <a:ln/>
+        </p:spPr>
+        <p:txBody>
+          <a:bodyPr wrap="square" lIns="0" tIns="0" rIns="0" bIns="0" rtlCol="0" anchor="ctr"/>
+          <a:lstStyle/>
+          <a:p>
+            <a:pPr indent="0" marL="0">
+              <a:buNone/>
+            </a:pPr>
+            <a:r>
+              <a:rPr lang="en-US" sz="1100" b="1" dirty="0">
+                <a:solidFill>
+                  <a:srgbClr val="1F3B57"/>
+                </a:solidFill>
+                <a:latin typeface="Arial" pitchFamily="34" charset="0"/>
+                <a:ea typeface="Arial" pitchFamily="34" charset="-122"/>
+                <a:cs typeface="Arial" pitchFamily="34" charset="-120"/>
+              </a:rPr>
+              <a:t>층 경계 특정</a:t>
+            </a:r>
+            <a:endParaRPr lang="en-US" sz="1100" dirty="0"/>
+          </a:p>
+        </p:txBody>
+      </p:sp>
+      <p:sp>
+        <p:nvSpPr>
+          <p:cNvPr id="26" name="Text 24"/>
+          <p:cNvSpPr/>
+          <p:nvPr/>
+        </p:nvSpPr>
+        <p:spPr>
+          <a:xfrm>
+            <a:off x="3566160" y="4974336"/>
+            <a:ext cx="3931920" cy="338328"/>
+          </a:xfrm>
+          <a:prstGeom prst="rect">
+            <a:avLst/>
+          </a:prstGeom>
+          <a:noFill/>
+          <a:ln/>
+        </p:spPr>
+        <p:txBody>
+          <a:bodyPr wrap="square" lIns="0" tIns="0" rIns="0" bIns="0" rtlCol="0" anchor="ctr"/>
+          <a:lstStyle/>
+          <a:p>
+            <a:pPr indent="0" marL="0">
+              <a:buNone/>
+            </a:pPr>
+            <a:r>
+              <a:rPr lang="en-US" sz="1050" dirty="0">
+                <a:solidFill>
+                  <a:srgbClr val="1F3B57"/>
+                </a:solidFill>
+                <a:latin typeface="Arial" pitchFamily="34" charset="0"/>
+                <a:ea typeface="Arial" pitchFamily="34" charset="-122"/>
+                <a:cs typeface="Arial" pitchFamily="34" charset="-120"/>
+              </a:rPr>
+              <a:t>통합은 앞쪽 16층에서 끝난다</a:t>
+            </a:r>
+            <a:endParaRPr lang="en-US" sz="1050" dirty="0"/>
+          </a:p>
+        </p:txBody>
+      </p:sp>
+      <p:sp>
+        <p:nvSpPr>
+          <p:cNvPr id="27" name="Text 25"/>
+          <p:cNvSpPr/>
+          <p:nvPr/>
+        </p:nvSpPr>
+        <p:spPr>
+          <a:xfrm>
+            <a:off x="7589520" y="4974336"/>
+            <a:ext cx="4023360" cy="338328"/>
+          </a:xfrm>
+          <a:prstGeom prst="rect">
+            <a:avLst/>
+          </a:prstGeom>
+          <a:noFill/>
+          <a:ln/>
+        </p:spPr>
+        <p:txBody>
+          <a:bodyPr wrap="square" lIns="0" tIns="0" rIns="0" bIns="0" rtlCol="0" anchor="ctr"/>
+          <a:lstStyle/>
+          <a:p>
+            <a:pPr indent="0" marL="0">
+              <a:buNone/>
+            </a:pPr>
+            <a:r>
+              <a:rPr lang="en-US" sz="1000" dirty="0">
+                <a:solidFill>
+                  <a:srgbClr val="6B7280"/>
+                </a:solidFill>
+                <a:latin typeface="Arial" pitchFamily="34" charset="0"/>
+                <a:ea typeface="Arial" pitchFamily="34" charset="-122"/>
+                <a:cs typeface="Arial" pitchFamily="34" charset="-120"/>
+              </a:rPr>
+              <a:t>ISO0 −0.055(유의) vs ISO16 −0.005</a:t>
+            </a:r>
+            <a:endParaRPr lang="en-US" sz="1000" dirty="0"/>
+          </a:p>
+        </p:txBody>
+      </p:sp>
+      <p:sp>
+        <p:nvSpPr>
+          <p:cNvPr id="28" name="Shape 26"/>
+          <p:cNvSpPr/>
+          <p:nvPr/>
+        </p:nvSpPr>
+        <p:spPr>
+          <a:xfrm>
+            <a:off x="502920" y="5349240"/>
+            <a:ext cx="11201400" cy="338328"/>
+          </a:xfrm>
+          <a:prstGeom prst="roundRect">
+            <a:avLst>
+              <a:gd name="adj" fmla="val 13514"/>
+            </a:avLst>
+          </a:prstGeom>
+          <a:solidFill>
+            <a:srgbClr val="EFF4F9"/>
+          </a:solidFill>
+          <a:ln/>
+        </p:spPr>
+      </p:sp>
+      <p:sp>
+        <p:nvSpPr>
+          <p:cNvPr id="29" name="Text 27"/>
+          <p:cNvSpPr/>
+          <p:nvPr/>
+        </p:nvSpPr>
+        <p:spPr>
+          <a:xfrm>
+            <a:off x="658368" y="5349240"/>
+            <a:ext cx="457200" cy="338328"/>
+          </a:xfrm>
+          <a:prstGeom prst="rect">
+            <a:avLst/>
+          </a:prstGeom>
+          <a:noFill/>
+          <a:ln/>
+        </p:spPr>
+        <p:txBody>
+          <a:bodyPr wrap="square" lIns="0" tIns="0" rIns="0" bIns="0" rtlCol="0" anchor="ctr"/>
+          <a:lstStyle/>
+          <a:p>
+            <a:pPr indent="0" marL="0">
+              <a:buNone/>
+            </a:pPr>
+            <a:r>
+              <a:rPr lang="en-US" sz="1100" b="1" dirty="0">
+                <a:solidFill>
+                  <a:srgbClr val="1F77B4"/>
+                </a:solidFill>
+                <a:latin typeface="Arial" pitchFamily="34" charset="0"/>
+                <a:ea typeface="Arial" pitchFamily="34" charset="-122"/>
+                <a:cs typeface="Arial" pitchFamily="34" charset="-120"/>
+              </a:rPr>
+              <a:t>C4</a:t>
+            </a:r>
+            <a:endParaRPr lang="en-US" sz="1100" dirty="0"/>
+          </a:p>
+        </p:txBody>
+      </p:sp>
+      <p:sp>
+        <p:nvSpPr>
+          <p:cNvPr id="30" name="Text 28"/>
+          <p:cNvSpPr/>
+          <p:nvPr/>
+        </p:nvSpPr>
+        <p:spPr>
+          <a:xfrm>
+            <a:off x="1188720" y="5349240"/>
+            <a:ext cx="2286000" cy="338328"/>
+          </a:xfrm>
+          <a:prstGeom prst="rect">
+            <a:avLst/>
+          </a:prstGeom>
+          <a:noFill/>
+          <a:ln/>
+        </p:spPr>
+        <p:txBody>
+          <a:bodyPr wrap="square" lIns="0" tIns="0" rIns="0" bIns="0" rtlCol="0" anchor="ctr"/>
+          <a:lstStyle/>
+          <a:p>
+            <a:pPr indent="0" marL="0">
+              <a:buNone/>
+            </a:pPr>
+            <a:r>
+              <a:rPr lang="en-US" sz="1100" b="1" dirty="0">
+                <a:solidFill>
+                  <a:srgbClr val="1F3B57"/>
+                </a:solidFill>
+                <a:latin typeface="Arial" pitchFamily="34" charset="0"/>
+                <a:ea typeface="Arial" pitchFamily="34" charset="-122"/>
+                <a:cs typeface="Arial" pitchFamily="34" charset="-120"/>
+              </a:rPr>
+              <a:t>모델 상대적 관련도</a:t>
+            </a:r>
+            <a:endParaRPr lang="en-US" sz="1100" dirty="0"/>
+          </a:p>
+        </p:txBody>
+      </p:sp>
+      <p:sp>
+        <p:nvSpPr>
+          <p:cNvPr id="31" name="Text 29"/>
+          <p:cNvSpPr/>
+          <p:nvPr/>
+        </p:nvSpPr>
+        <p:spPr>
+          <a:xfrm>
+            <a:off x="3566160" y="5349240"/>
+            <a:ext cx="3931920" cy="338328"/>
+          </a:xfrm>
+          <a:prstGeom prst="rect">
+            <a:avLst/>
+          </a:prstGeom>
+          <a:noFill/>
+          <a:ln/>
+        </p:spPr>
+        <p:txBody>
+          <a:bodyPr wrap="square" lIns="0" tIns="0" rIns="0" bIns="0" rtlCol="0" anchor="ctr"/>
+          <a:lstStyle/>
+          <a:p>
+            <a:pPr indent="0" marL="0">
+              <a:buNone/>
+            </a:pPr>
+            <a:r>
+              <a:rPr lang="en-US" sz="1050" dirty="0">
+                <a:solidFill>
+                  <a:srgbClr val="1F3B57"/>
+                </a:solidFill>
+                <a:latin typeface="Arial" pitchFamily="34" charset="0"/>
+                <a:ea typeface="Arial" pitchFamily="34" charset="-122"/>
+                <a:cs typeface="Arial" pitchFamily="34" charset="-120"/>
+              </a:rPr>
+              <a:t>의미 유사도로는 못 푼다</a:t>
+            </a:r>
+            <a:endParaRPr lang="en-US" sz="1050" dirty="0"/>
+          </a:p>
+        </p:txBody>
+      </p:sp>
+      <p:sp>
+        <p:nvSpPr>
+          <p:cNvPr id="32" name="Text 30"/>
+          <p:cNvSpPr/>
+          <p:nvPr/>
+        </p:nvSpPr>
+        <p:spPr>
+          <a:xfrm>
+            <a:off x="7589520" y="5349240"/>
+            <a:ext cx="4023360" cy="338328"/>
+          </a:xfrm>
+          <a:prstGeom prst="rect">
+            <a:avLst/>
+          </a:prstGeom>
+          <a:noFill/>
+          <a:ln/>
+        </p:spPr>
+        <p:txBody>
+          <a:bodyPr wrap="square" lIns="0" tIns="0" rIns="0" bIns="0" rtlCol="0" anchor="ctr"/>
+          <a:lstStyle/>
+          <a:p>
+            <a:pPr indent="0" marL="0">
+              <a:buNone/>
+            </a:pPr>
+            <a:r>
+              <a:rPr lang="en-US" sz="1000" dirty="0">
+                <a:solidFill>
+                  <a:srgbClr val="6B7280"/>
+                </a:solidFill>
+                <a:latin typeface="Arial" pitchFamily="34" charset="0"/>
+                <a:ea typeface="Arial" pitchFamily="34" charset="-122"/>
+                <a:cs typeface="Arial" pitchFamily="34" charset="-120"/>
+              </a:rPr>
+              <a:t>CLIP 0.51/0.39/0.33 vs 우리 0.69/0.71/0.73</a:t>
+            </a:r>
+            <a:endParaRPr lang="en-US" sz="1000" dirty="0"/>
+          </a:p>
+        </p:txBody>
+      </p:sp>
+      <p:sp>
+        <p:nvSpPr>
+          <p:cNvPr id="33" name="Shape 31"/>
+          <p:cNvSpPr/>
+          <p:nvPr/>
+        </p:nvSpPr>
+        <p:spPr>
+          <a:xfrm>
+            <a:off x="502920" y="5724144"/>
+            <a:ext cx="11201400" cy="338328"/>
+          </a:xfrm>
+          <a:prstGeom prst="roundRect">
+            <a:avLst>
+              <a:gd name="adj" fmla="val 13514"/>
+            </a:avLst>
+          </a:prstGeom>
+          <a:solidFill>
+            <a:srgbClr val="F3F4F6"/>
+          </a:solidFill>
+          <a:ln/>
+        </p:spPr>
+      </p:sp>
+      <p:sp>
+        <p:nvSpPr>
+          <p:cNvPr id="34" name="Text 32"/>
+          <p:cNvSpPr/>
+          <p:nvPr/>
+        </p:nvSpPr>
+        <p:spPr>
+          <a:xfrm>
+            <a:off x="658368" y="5724144"/>
+            <a:ext cx="457200" cy="338328"/>
+          </a:xfrm>
+          <a:prstGeom prst="rect">
+            <a:avLst/>
+          </a:prstGeom>
+          <a:noFill/>
+          <a:ln/>
+        </p:spPr>
+        <p:txBody>
+          <a:bodyPr wrap="square" lIns="0" tIns="0" rIns="0" bIns="0" rtlCol="0" anchor="ctr"/>
+          <a:lstStyle/>
+          <a:p>
+            <a:pPr indent="0" marL="0">
+              <a:buNone/>
+            </a:pPr>
+            <a:r>
+              <a:rPr lang="en-US" sz="1100" b="1" dirty="0">
+                <a:solidFill>
+                  <a:srgbClr val="1F77B4"/>
+                </a:solidFill>
+                <a:latin typeface="Arial" pitchFamily="34" charset="0"/>
+                <a:ea typeface="Arial" pitchFamily="34" charset="-122"/>
+                <a:cs typeface="Arial" pitchFamily="34" charset="-120"/>
+              </a:rPr>
+              <a:t>C5</a:t>
+            </a:r>
+            <a:endParaRPr lang="en-US" sz="1100" dirty="0"/>
+          </a:p>
+        </p:txBody>
+      </p:sp>
+      <p:sp>
+        <p:nvSpPr>
+          <p:cNvPr id="35" name="Text 33"/>
+          <p:cNvSpPr/>
+          <p:nvPr/>
+        </p:nvSpPr>
+        <p:spPr>
+          <a:xfrm>
+            <a:off x="1188720" y="5724144"/>
+            <a:ext cx="2286000" cy="338328"/>
+          </a:xfrm>
+          <a:prstGeom prst="rect">
+            <a:avLst/>
+          </a:prstGeom>
+          <a:noFill/>
+          <a:ln/>
+        </p:spPr>
+        <p:txBody>
+          <a:bodyPr wrap="square" lIns="0" tIns="0" rIns="0" bIns="0" rtlCol="0" anchor="ctr"/>
+          <a:lstStyle/>
+          <a:p>
+            <a:pPr indent="0" marL="0">
+              <a:buNone/>
+            </a:pPr>
+            <a:r>
+              <a:rPr lang="en-US" sz="1100" b="1" dirty="0">
+                <a:solidFill>
+                  <a:srgbClr val="1F3B57"/>
+                </a:solidFill>
+                <a:latin typeface="Arial" pitchFamily="34" charset="0"/>
+                <a:ea typeface="Arial" pitchFamily="34" charset="-122"/>
+                <a:cs typeface="Arial" pitchFamily="34" charset="-120"/>
+              </a:rPr>
+              <a:t>오라클 없는 컨트롤러</a:t>
+            </a:r>
+            <a:endParaRPr lang="en-US" sz="1100" dirty="0"/>
+          </a:p>
+        </p:txBody>
+      </p:sp>
+      <p:sp>
+        <p:nvSpPr>
+          <p:cNvPr id="36" name="Text 34"/>
+          <p:cNvSpPr/>
+          <p:nvPr/>
+        </p:nvSpPr>
+        <p:spPr>
+          <a:xfrm>
+            <a:off x="3566160" y="5724144"/>
+            <a:ext cx="3931920" cy="338328"/>
+          </a:xfrm>
+          <a:prstGeom prst="rect">
+            <a:avLst/>
+          </a:prstGeom>
+          <a:noFill/>
+          <a:ln/>
+        </p:spPr>
+        <p:txBody>
+          <a:bodyPr wrap="square" lIns="0" tIns="0" rIns="0" bIns="0" rtlCol="0" anchor="ctr"/>
+          <a:lstStyle/>
+          <a:p>
+            <a:pPr indent="0" marL="0">
+              <a:buNone/>
+            </a:pPr>
+            <a:r>
+              <a:rPr lang="en-US" sz="1050" dirty="0">
+                <a:solidFill>
+                  <a:srgbClr val="1F3B57"/>
+                </a:solidFill>
+                <a:latin typeface="Arial" pitchFamily="34" charset="0"/>
+                <a:ea typeface="Arial" pitchFamily="34" charset="-122"/>
+                <a:cs typeface="Arial" pitchFamily="34" charset="-120"/>
+              </a:rPr>
+              <a:t>반사실 신호가 손익분기를 넘는다</a:t>
+            </a:r>
+            <a:endParaRPr lang="en-US" sz="1050" dirty="0"/>
+          </a:p>
+        </p:txBody>
+      </p:sp>
+      <p:sp>
+        <p:nvSpPr>
+          <p:cNvPr id="37" name="Text 35"/>
+          <p:cNvSpPr/>
+          <p:nvPr/>
+        </p:nvSpPr>
+        <p:spPr>
+          <a:xfrm>
+            <a:off x="7589520" y="5724144"/>
+            <a:ext cx="4023360" cy="338328"/>
+          </a:xfrm>
+          <a:prstGeom prst="rect">
+            <a:avLst/>
+          </a:prstGeom>
+          <a:noFill/>
+          <a:ln/>
+        </p:spPr>
+        <p:txBody>
+          <a:bodyPr wrap="square" lIns="0" tIns="0" rIns="0" bIns="0" rtlCol="0" anchor="ctr"/>
+          <a:lstStyle/>
+          <a:p>
+            <a:pPr indent="0" marL="0">
+              <a:buNone/>
+            </a:pPr>
+            <a:r>
+              <a:rPr lang="en-US" sz="1000" dirty="0">
+                <a:solidFill>
+                  <a:srgbClr val="6B7280"/>
+                </a:solidFill>
+                <a:latin typeface="Arial" pitchFamily="34" charset="0"/>
+                <a:ea typeface="Arial" pitchFamily="34" charset="-122"/>
+                <a:cs typeface="Arial" pitchFamily="34" charset="-120"/>
+              </a:rPr>
+              <a:t>3B N=3 무개입 대비 +18.2%p</a:t>
+            </a:r>
+            <a:endParaRPr lang="en-US" sz="1000" dirty="0"/>
+          </a:p>
+        </p:txBody>
+      </p:sp>
+      <p:sp>
+        <p:nvSpPr>
+          <p:cNvPr id="38" name="Shape 36"/>
+          <p:cNvSpPr/>
+          <p:nvPr/>
+        </p:nvSpPr>
+        <p:spPr>
+          <a:xfrm>
+            <a:off x="502920" y="6053328"/>
+            <a:ext cx="11201400" cy="548640"/>
+          </a:xfrm>
+          <a:prstGeom prst="roundRect">
+            <a:avLst>
+              <a:gd name="adj" fmla="val 13333"/>
+            </a:avLst>
+          </a:prstGeom>
+          <a:solidFill>
+            <a:srgbClr val="1F3B57"/>
+          </a:solidFill>
+          <a:ln/>
+        </p:spPr>
+      </p:sp>
+      <p:sp>
+        <p:nvSpPr>
+          <p:cNvPr id="39" name="Text 37"/>
+          <p:cNvSpPr/>
+          <p:nvPr/>
+        </p:nvSpPr>
+        <p:spPr>
+          <a:xfrm>
+            <a:off x="777240" y="6053328"/>
+            <a:ext cx="10744200" cy="548640"/>
+          </a:xfrm>
+          <a:prstGeom prst="rect">
+            <a:avLst/>
+          </a:prstGeom>
+          <a:noFill/>
+          <a:ln/>
+        </p:spPr>
+        <p:txBody>
+          <a:bodyPr wrap="square" lIns="0" tIns="0" rIns="0" bIns="0" rtlCol="0" anchor="ctr"/>
+          <a:lstStyle/>
+          <a:p>
+            <a:pPr indent="0" marL="0">
+              <a:buNone/>
+            </a:pPr>
+            <a:r>
+              <a:rPr lang="en-US" sz="1250" b="1" dirty="0">
+                <a:solidFill>
+                  <a:srgbClr val="FFFFFF"/>
+                </a:solidFill>
+                <a:latin typeface="Arial" pitchFamily="34" charset="0"/>
+                <a:ea typeface="Arial" pitchFamily="34" charset="-122"/>
+                <a:cs typeface="Arial" pitchFamily="34" charset="-120"/>
+              </a:rPr>
+              <a:t>→ 차별성: 이미지↔이미지 edge의 layer 분해 knockout은 문헌에 0편. 무관 이미지 레짐 자체를 CAPL·SoFA는 실험한 적이 없습니다</a:t>
+            </a:r>
+            <a:endParaRPr lang="en-US" sz="1250" dirty="0"/>
+          </a:p>
+        </p:txBody>
+      </p:sp>
+    </p:spTree>
+  </p:cSld>
+  <p:clrMapOvr>
+    <a:masterClrMapping/>
+  </p:clrMapOvr>
+</p:sld>
+</file>
+
+<file path=ppt/slides/slide3.xml><?xml version="1.0" encoding="utf-8"?>
+<p:sld xmlns:a="http://schemas.openxmlformats.org/drawingml/2006/main" xmlns:r="http://schemas.openxmlformats.org/officeDocument/2006/relationships" xmlns:p="http://schemas.openxmlformats.org/presentationml/2006/main">
+  <p:cSld name="Slide 3">
     <p:spTree>
       <p:nvGrpSpPr>
         <p:cNvPr id="1" name=""/>
@@ -3505,7 +5944,7 @@
       </p:sp>
       <p:graphicFrame>
         <p:nvGraphicFramePr>
-          <p:cNvPr id="3" name="Table 0"/>
+          <p:cNvPr id="4" name="Table 0"/>
           <p:cNvGraphicFramePr>
             <a:graphicFrameLocks noGrp="1"/>
           </p:cNvGraphicFramePr>
@@ -5110,9 +7549,9 @@
 </p:sld>
 </file>
 
-<file path=ppt/slides/slide3.xml><?xml version="1.0" encoding="utf-8"?>
+<file path=ppt/slides/slide4.xml><?xml version="1.0" encoding="utf-8"?>
 <p:sld xmlns:a="http://schemas.openxmlformats.org/drawingml/2006/main" xmlns:r="http://schemas.openxmlformats.org/officeDocument/2006/relationships" xmlns:p="http://schemas.openxmlformats.org/presentationml/2006/main">
-  <p:cSld name="Slide 3">
+  <p:cSld name="Slide 4">
     <p:spTree>
       <p:nvGrpSpPr>
         <p:cNvPr id="1" name=""/>
@@ -5207,7 +7646,7 @@
       </p:sp>
       <p:graphicFrame>
         <p:nvGraphicFramePr>
-          <p:cNvPr id="4" name="Table 0"/>
+          <p:cNvPr id="5" name="Table 0"/>
           <p:cNvGraphicFramePr>
             <a:graphicFrameLocks noGrp="1"/>
           </p:cNvGraphicFramePr>
@@ -7898,9 +10337,9 @@
 </p:sld>
 </file>
 
-<file path=ppt/slides/slide4.xml><?xml version="1.0" encoding="utf-8"?>
+<file path=ppt/slides/slide5.xml><?xml version="1.0" encoding="utf-8"?>
 <p:sld xmlns:a="http://schemas.openxmlformats.org/drawingml/2006/main" xmlns:r="http://schemas.openxmlformats.org/officeDocument/2006/relationships" xmlns:p="http://schemas.openxmlformats.org/presentationml/2006/main">
-  <p:cSld name="Slide 4">
+  <p:cSld name="Slide 5">
     <p:spTree>
       <p:nvGrpSpPr>
         <p:cNvPr id="1" name=""/>
@@ -8034,7 +10473,7 @@
       </p:sp>
       <p:graphicFrame>
         <p:nvGraphicFramePr>
-          <p:cNvPr id="5" name="Table 0"/>
+          <p:cNvPr id="6" name="Table 0"/>
           <p:cNvGraphicFramePr>
             <a:graphicFrameLocks noGrp="1"/>
           </p:cNvGraphicFramePr>
@@ -10568,9 +13007,9 @@
 </p:sld>
 </file>
 
-<file path=ppt/slides/slide5.xml><?xml version="1.0" encoding="utf-8"?>
+<file path=ppt/slides/slide6.xml><?xml version="1.0" encoding="utf-8"?>
 <p:sld xmlns:a="http://schemas.openxmlformats.org/drawingml/2006/main" xmlns:r="http://schemas.openxmlformats.org/officeDocument/2006/relationships" xmlns:p="http://schemas.openxmlformats.org/presentationml/2006/main">
-  <p:cSld name="Slide 5">
+  <p:cSld name="Slide 6">
     <p:spTree>
       <p:nvGrpSpPr>
         <p:cNvPr id="1" name=""/>
@@ -10665,7 +13104,7 @@
       </p:sp>
       <p:graphicFrame>
         <p:nvGraphicFramePr>
-          <p:cNvPr id="6" name="Table 0"/>
+          <p:cNvPr id="7" name="Table 0"/>
           <p:cNvGraphicFramePr>
             <a:graphicFrameLocks noGrp="1"/>
           </p:cNvGraphicFramePr>
@@ -12066,9 +14505,9 @@
 </p:sld>
 </file>
 
-<file path=ppt/slides/slide6.xml><?xml version="1.0" encoding="utf-8"?>
+<file path=ppt/slides/slide7.xml><?xml version="1.0" encoding="utf-8"?>
 <p:sld xmlns:a="http://schemas.openxmlformats.org/drawingml/2006/main" xmlns:r="http://schemas.openxmlformats.org/officeDocument/2006/relationships" xmlns:p="http://schemas.openxmlformats.org/presentationml/2006/main">
-  <p:cSld name="Slide 6">
+  <p:cSld name="Slide 7">
     <p:spTree>
       <p:nvGrpSpPr>
         <p:cNvPr id="1" name=""/>
@@ -12163,7 +14602,7 @@
       </p:sp>
       <p:graphicFrame>
         <p:nvGraphicFramePr>
-          <p:cNvPr id="7" name="Table 0"/>
+          <p:cNvPr id="8" name="Table 0"/>
           <p:cNvGraphicFramePr>
             <a:graphicFrameLocks noGrp="1"/>
           </p:cNvGraphicFramePr>
@@ -14620,9 +17059,9 @@
 </p:sld>
 </file>
 
-<file path=ppt/slides/slide7.xml><?xml version="1.0" encoding="utf-8"?>
+<file path=ppt/slides/slide8.xml><?xml version="1.0" encoding="utf-8"?>
 <p:sld xmlns:a="http://schemas.openxmlformats.org/drawingml/2006/main" xmlns:r="http://schemas.openxmlformats.org/officeDocument/2006/relationships" xmlns:p="http://schemas.openxmlformats.org/presentationml/2006/main">
-  <p:cSld name="Slide 7">
+  <p:cSld name="Slide 8">
     <p:spTree>
       <p:nvGrpSpPr>
         <p:cNvPr id="1" name=""/>
@@ -14717,7 +17156,7 @@
       </p:sp>
       <p:graphicFrame>
         <p:nvGraphicFramePr>
-          <p:cNvPr id="8" name="Table 0"/>
+          <p:cNvPr id="9" name="Table 0"/>
           <p:cNvGraphicFramePr>
             <a:graphicFrameLocks noGrp="1"/>
           </p:cNvGraphicFramePr>
@@ -15560,7 +17999,7 @@
       </p:graphicFrame>
       <p:graphicFrame>
         <p:nvGraphicFramePr>
-          <p:cNvPr id="15" name="Table 1"/>
+          <p:cNvPr id="17" name="Table 1"/>
           <p:cNvGraphicFramePr>
             <a:graphicFrameLocks noGrp="1"/>
           </p:cNvGraphicFramePr>
@@ -18195,9 +20634,9 @@
 </p:sld>
 </file>
 
-<file path=ppt/slides/slide8.xml><?xml version="1.0" encoding="utf-8"?>
+<file path=ppt/slides/slide9.xml><?xml version="1.0" encoding="utf-8"?>
 <p:sld xmlns:a="http://schemas.openxmlformats.org/drawingml/2006/main" xmlns:r="http://schemas.openxmlformats.org/officeDocument/2006/relationships" xmlns:p="http://schemas.openxmlformats.org/presentationml/2006/main">
-  <p:cSld name="Slide 8">
+  <p:cSld name="Slide 9">
     <p:spTree>
       <p:nvGrpSpPr>
         <p:cNvPr id="1" name=""/>
@@ -18292,7 +20731,7 @@
       </p:sp>
       <p:graphicFrame>
         <p:nvGraphicFramePr>
-          <p:cNvPr id="9" name="Table 0"/>
+          <p:cNvPr id="10" name="Table 0"/>
           <p:cNvGraphicFramePr>
             <a:graphicFrameLocks noGrp="1"/>
           </p:cNvGraphicFramePr>
@@ -20416,7 +22855,7 @@
       </p:sp>
       <p:graphicFrame>
         <p:nvGraphicFramePr>
-          <p:cNvPr id="17" name="Table 1"/>
+          <p:cNvPr id="19" name="Table 1"/>
           <p:cNvGraphicFramePr>
             <a:graphicFrameLocks noGrp="1"/>
           </p:cNvGraphicFramePr>
@@ -21605,848 +24044,6 @@
                 <a:cs typeface="Arial" pitchFamily="34" charset="-120"/>
               </a:rPr>
               <a:t>→ 가설 정정에 따라 'neg attention으로 뒤쪽 층에서 분리'는 폐기합니다 — 분리할 대상이 문제가 아니었습니다</a:t>
-            </a:r>
-            <a:endParaRPr lang="en-US" sz="1250" dirty="0"/>
-          </a:p>
-        </p:txBody>
-      </p:sp>
-    </p:spTree>
-  </p:cSld>
-  <p:clrMapOvr>
-    <a:masterClrMapping/>
-  </p:clrMapOvr>
-</p:sld>
-</file>
-
-<file path=ppt/slides/slide9.xml><?xml version="1.0" encoding="utf-8"?>
-<p:sld xmlns:a="http://schemas.openxmlformats.org/drawingml/2006/main" xmlns:r="http://schemas.openxmlformats.org/officeDocument/2006/relationships" xmlns:p="http://schemas.openxmlformats.org/presentationml/2006/main">
-  <p:cSld name="Slide 9">
-    <p:spTree>
-      <p:nvGrpSpPr>
-        <p:cNvPr id="1" name=""/>
-        <p:cNvGrpSpPr/>
-        <p:nvPr/>
-      </p:nvGrpSpPr>
-      <p:grpSpPr>
-        <a:xfrm>
-          <a:off x="0" y="0"/>
-          <a:ext cx="0" cy="0"/>
-          <a:chOff x="0" y="0"/>
-          <a:chExt cx="0" cy="0"/>
-        </a:xfrm>
-      </p:grpSpPr>
-      <p:sp>
-        <p:nvSpPr>
-          <p:cNvPr id="2" name="Text 0"/>
-          <p:cNvSpPr/>
-          <p:nvPr/>
-        </p:nvSpPr>
-        <p:spPr>
-          <a:xfrm>
-            <a:off x="502920" y="237744"/>
-            <a:ext cx="10515600" cy="274320"/>
-          </a:xfrm>
-          <a:prstGeom prst="rect">
-            <a:avLst/>
-          </a:prstGeom>
-          <a:noFill/>
-          <a:ln/>
-        </p:spPr>
-        <p:txBody>
-          <a:bodyPr wrap="square" lIns="0" tIns="0" rIns="0" bIns="0" rtlCol="0" anchor="ctr"/>
-          <a:lstStyle/>
-          <a:p>
-            <a:pPr indent="0" marL="0">
-              <a:buNone/>
-            </a:pPr>
-            <a:r>
-              <a:rPr lang="en-US" sz="1100" b="1" dirty="0">
-                <a:solidFill>
-                  <a:srgbClr val="1F77B4"/>
-                </a:solidFill>
-                <a:latin typeface="Arial" pitchFamily="34" charset="0"/>
-                <a:ea typeface="Arial" pitchFamily="34" charset="-122"/>
-                <a:cs typeface="Arial" pitchFamily="34" charset="-120"/>
-              </a:rPr>
-              <a:t>정직한 한계</a:t>
-            </a:r>
-            <a:endParaRPr lang="en-US" sz="1100" dirty="0"/>
-          </a:p>
-        </p:txBody>
-      </p:sp>
-      <p:sp>
-        <p:nvSpPr>
-          <p:cNvPr id="3" name="Text 1"/>
-          <p:cNvSpPr/>
-          <p:nvPr/>
-        </p:nvSpPr>
-        <p:spPr>
-          <a:xfrm>
-            <a:off x="502920" y="493776"/>
-            <a:ext cx="11155680" cy="658368"/>
-          </a:xfrm>
-          <a:prstGeom prst="rect">
-            <a:avLst/>
-          </a:prstGeom>
-          <a:noFill/>
-          <a:ln/>
-        </p:spPr>
-        <p:txBody>
-          <a:bodyPr wrap="square" lIns="0" tIns="0" rIns="0" bIns="0" rtlCol="0" anchor="ctr"/>
-          <a:lstStyle/>
-          <a:p>
-            <a:pPr indent="0" marL="0">
-              <a:buNone/>
-            </a:pPr>
-            <a:r>
-              <a:rPr lang="en-US" sz="2100" b="1" dirty="0">
-                <a:solidFill>
-                  <a:srgbClr val="1F3B57"/>
-                </a:solidFill>
-                <a:latin typeface="Arial" pitchFamily="34" charset="0"/>
-                <a:ea typeface="Arial" pitchFamily="34" charset="-122"/>
-                <a:cs typeface="Arial" pitchFamily="34" charset="-120"/>
-              </a:rPr>
-              <a:t>지금 이 연구를 무너뜨릴 수 있는 것 세 가지</a:t>
-            </a:r>
-            <a:endParaRPr lang="en-US" sz="2100" dirty="0"/>
-          </a:p>
-        </p:txBody>
-      </p:sp>
-      <p:sp>
-        <p:nvSpPr>
-          <p:cNvPr id="4" name="Shape 2"/>
-          <p:cNvSpPr/>
-          <p:nvPr/>
-        </p:nvSpPr>
-        <p:spPr>
-          <a:xfrm>
-            <a:off x="502920" y="1298448"/>
-            <a:ext cx="11201400" cy="1408176"/>
-          </a:xfrm>
-          <a:prstGeom prst="roundRect">
-            <a:avLst>
-              <a:gd name="adj" fmla="val 5195"/>
-            </a:avLst>
-          </a:prstGeom>
-          <a:solidFill>
-            <a:srgbClr val="FBEAEA"/>
-          </a:solidFill>
-          <a:ln w="12700">
-            <a:solidFill>
-              <a:srgbClr val="D62728"/>
-            </a:solidFill>
-            <a:prstDash val="solid"/>
-          </a:ln>
-        </p:spPr>
-      </p:sp>
-      <p:sp>
-        <p:nvSpPr>
-          <p:cNvPr id="5" name="Shape 3"/>
-          <p:cNvSpPr/>
-          <p:nvPr/>
-        </p:nvSpPr>
-        <p:spPr>
-          <a:xfrm>
-            <a:off x="749808" y="1463040"/>
-            <a:ext cx="402336" cy="402336"/>
-          </a:xfrm>
-          <a:prstGeom prst="ellipse">
-            <a:avLst/>
-          </a:prstGeom>
-          <a:solidFill>
-            <a:srgbClr val="D62728"/>
-          </a:solidFill>
-          <a:ln/>
-        </p:spPr>
-      </p:sp>
-      <p:sp>
-        <p:nvSpPr>
-          <p:cNvPr id="6" name="Text 4"/>
-          <p:cNvSpPr/>
-          <p:nvPr/>
-        </p:nvSpPr>
-        <p:spPr>
-          <a:xfrm>
-            <a:off x="749808" y="1463040"/>
-            <a:ext cx="402336" cy="402336"/>
-          </a:xfrm>
-          <a:prstGeom prst="rect">
-            <a:avLst/>
-          </a:prstGeom>
-          <a:noFill/>
-          <a:ln/>
-        </p:spPr>
-        <p:txBody>
-          <a:bodyPr wrap="square" lIns="0" tIns="0" rIns="0" bIns="0" rtlCol="0" anchor="ctr"/>
-          <a:lstStyle/>
-          <a:p>
-            <a:pPr algn="ctr" indent="0" marL="0">
-              <a:buNone/>
-            </a:pPr>
-            <a:r>
-              <a:rPr lang="en-US" sz="1300" b="1" dirty="0">
-                <a:solidFill>
-                  <a:srgbClr val="FFFFFF"/>
-                </a:solidFill>
-                <a:latin typeface="Arial" pitchFamily="34" charset="0"/>
-                <a:ea typeface="Arial" pitchFamily="34" charset="-122"/>
-                <a:cs typeface="Arial" pitchFamily="34" charset="-120"/>
-              </a:rPr>
-              <a:t>1</a:t>
-            </a:r>
-            <a:endParaRPr lang="en-US" sz="1300" dirty="0"/>
-          </a:p>
-        </p:txBody>
-      </p:sp>
-      <p:sp>
-        <p:nvSpPr>
-          <p:cNvPr id="7" name="Text 5"/>
-          <p:cNvSpPr/>
-          <p:nvPr/>
-        </p:nvSpPr>
-        <p:spPr>
-          <a:xfrm>
-            <a:off x="1316736" y="1444752"/>
-            <a:ext cx="10149840" cy="274320"/>
-          </a:xfrm>
-          <a:prstGeom prst="rect">
-            <a:avLst/>
-          </a:prstGeom>
-          <a:noFill/>
-          <a:ln/>
-        </p:spPr>
-        <p:txBody>
-          <a:bodyPr wrap="square" lIns="0" tIns="0" rIns="0" bIns="0" rtlCol="0" anchor="ctr"/>
-          <a:lstStyle/>
-          <a:p>
-            <a:pPr indent="0" marL="0">
-              <a:buNone/>
-            </a:pPr>
-            <a:r>
-              <a:rPr lang="en-US" sz="1300" b="1" dirty="0">
-                <a:solidFill>
-                  <a:srgbClr val="1F3B57"/>
-                </a:solidFill>
-                <a:latin typeface="Arial" pitchFamily="34" charset="0"/>
-                <a:ea typeface="Arial" pitchFamily="34" charset="-122"/>
-                <a:cs typeface="Arial" pitchFamily="34" charset="-120"/>
-              </a:rPr>
-              <a:t>벤치마크가 위치로 대상을 지목한다</a:t>
-            </a:r>
-            <a:endParaRPr lang="en-US" sz="1300" dirty="0"/>
-          </a:p>
-        </p:txBody>
-      </p:sp>
-      <p:sp>
-        <p:nvSpPr>
-          <p:cNvPr id="8" name="Text 6"/>
-          <p:cNvSpPr/>
-          <p:nvPr/>
-        </p:nvSpPr>
-        <p:spPr>
-          <a:xfrm>
-            <a:off x="1316736" y="1755648"/>
-            <a:ext cx="10149840" cy="548640"/>
-          </a:xfrm>
-          <a:prstGeom prst="rect">
-            <a:avLst/>
-          </a:prstGeom>
-          <a:noFill/>
-          <a:ln/>
-        </p:spPr>
-        <p:txBody>
-          <a:bodyPr wrap="square" lIns="0" tIns="0" rIns="0" bIns="0" rtlCol="0" anchor="ctr"/>
-          <a:lstStyle/>
-          <a:p>
-            <a:pPr indent="0" marL="0">
-              <a:lnSpc>
-                <a:spcPct val="115000"/>
-              </a:lnSpc>
-              <a:buNone/>
-            </a:pPr>
-            <a:r>
-              <a:rPr lang="en-US" sz="1100" dirty="0">
-                <a:solidFill>
-                  <a:srgbClr val="1F3B57"/>
-                </a:solidFill>
-                <a:latin typeface="Arial" pitchFamily="34" charset="0"/>
-                <a:ea typeface="Arial" pitchFamily="34" charset="-122"/>
-                <a:cs typeface="Arial" pitchFamily="34" charset="-120"/>
-              </a:rPr>
-              <a:t>질문이 "첫 번째 이미지에"로 시작하므로, 앞단 모듈이 텍스트만 파싱해도 100% 맞힙니다.</a:t>
-            </a:r>
-            <a:endParaRPr lang="en-US" sz="1100" dirty="0"/>
-          </a:p>
-          <a:p>
-            <a:pPr indent="0" marL="0">
-              <a:lnSpc>
-                <a:spcPct val="115000"/>
-              </a:lnSpc>
-              <a:buNone/>
-            </a:pPr>
-            <a:r>
-              <a:rPr lang="en-US" sz="1100" dirty="0">
-                <a:solidFill>
-                  <a:srgbClr val="1F3B57"/>
-                </a:solidFill>
-                <a:latin typeface="Arial" pitchFamily="34" charset="0"/>
-                <a:ea typeface="Arial" pitchFamily="34" charset="-122"/>
-                <a:cs typeface="Arial" pitchFamily="34" charset="-120"/>
-              </a:rPr>
-              <a:t>현 벤치마크로는 '내부 개입이어야 하는 이유'를 증명할 수 없습니다.</a:t>
-            </a:r>
-            <a:endParaRPr lang="en-US" sz="1100" dirty="0"/>
-          </a:p>
-        </p:txBody>
-      </p:sp>
-      <p:sp>
-        <p:nvSpPr>
-          <p:cNvPr id="9" name="Text 7"/>
-          <p:cNvSpPr/>
-          <p:nvPr/>
-        </p:nvSpPr>
-        <p:spPr>
-          <a:xfrm>
-            <a:off x="1316736" y="2340864"/>
-            <a:ext cx="10149840" cy="274320"/>
-          </a:xfrm>
-          <a:prstGeom prst="rect">
-            <a:avLst/>
-          </a:prstGeom>
-          <a:noFill/>
-          <a:ln/>
-        </p:spPr>
-        <p:txBody>
-          <a:bodyPr wrap="square" lIns="0" tIns="0" rIns="0" bIns="0" rtlCol="0" anchor="ctr"/>
-          <a:lstStyle/>
-          <a:p>
-            <a:pPr indent="0" marL="0">
-              <a:buNone/>
-            </a:pPr>
-            <a:r>
-              <a:rPr lang="en-US" sz="1100" b="1" dirty="0">
-                <a:solidFill>
-                  <a:srgbClr val="2E8B57"/>
-                </a:solidFill>
-                <a:latin typeface="Arial" pitchFamily="34" charset="0"/>
-                <a:ea typeface="Arial" pitchFamily="34" charset="-122"/>
-                <a:cs typeface="Arial" pitchFamily="34" charset="-120"/>
-              </a:rPr>
-              <a:t>대응: 관련도가 추론의 결과인 질문으로 교체 — all-of-3 세트 측정 중</a:t>
-            </a:r>
-            <a:endParaRPr lang="en-US" sz="1100" dirty="0"/>
-          </a:p>
-        </p:txBody>
-      </p:sp>
-      <p:sp>
-        <p:nvSpPr>
-          <p:cNvPr id="10" name="Shape 8"/>
-          <p:cNvSpPr/>
-          <p:nvPr/>
-        </p:nvSpPr>
-        <p:spPr>
-          <a:xfrm>
-            <a:off x="502920" y="2834640"/>
-            <a:ext cx="11201400" cy="1408176"/>
-          </a:xfrm>
-          <a:prstGeom prst="roundRect">
-            <a:avLst>
-              <a:gd name="adj" fmla="val 5195"/>
-            </a:avLst>
-          </a:prstGeom>
-          <a:solidFill>
-            <a:srgbClr val="FBEAEA"/>
-          </a:solidFill>
-          <a:ln w="12700">
-            <a:solidFill>
-              <a:srgbClr val="D62728"/>
-            </a:solidFill>
-            <a:prstDash val="solid"/>
-          </a:ln>
-        </p:spPr>
-      </p:sp>
-      <p:sp>
-        <p:nvSpPr>
-          <p:cNvPr id="11" name="Shape 9"/>
-          <p:cNvSpPr/>
-          <p:nvPr/>
-        </p:nvSpPr>
-        <p:spPr>
-          <a:xfrm>
-            <a:off x="749808" y="2999232"/>
-            <a:ext cx="402336" cy="402336"/>
-          </a:xfrm>
-          <a:prstGeom prst="ellipse">
-            <a:avLst/>
-          </a:prstGeom>
-          <a:solidFill>
-            <a:srgbClr val="D62728"/>
-          </a:solidFill>
-          <a:ln/>
-        </p:spPr>
-      </p:sp>
-      <p:sp>
-        <p:nvSpPr>
-          <p:cNvPr id="12" name="Text 10"/>
-          <p:cNvSpPr/>
-          <p:nvPr/>
-        </p:nvSpPr>
-        <p:spPr>
-          <a:xfrm>
-            <a:off x="749808" y="2999232"/>
-            <a:ext cx="402336" cy="402336"/>
-          </a:xfrm>
-          <a:prstGeom prst="rect">
-            <a:avLst/>
-          </a:prstGeom>
-          <a:noFill/>
-          <a:ln/>
-        </p:spPr>
-        <p:txBody>
-          <a:bodyPr wrap="square" lIns="0" tIns="0" rIns="0" bIns="0" rtlCol="0" anchor="ctr"/>
-          <a:lstStyle/>
-          <a:p>
-            <a:pPr algn="ctr" indent="0" marL="0">
-              <a:buNone/>
-            </a:pPr>
-            <a:r>
-              <a:rPr lang="en-US" sz="1300" b="1" dirty="0">
-                <a:solidFill>
-                  <a:srgbClr val="FFFFFF"/>
-                </a:solidFill>
-                <a:latin typeface="Arial" pitchFamily="34" charset="0"/>
-                <a:ea typeface="Arial" pitchFamily="34" charset="-122"/>
-                <a:cs typeface="Arial" pitchFamily="34" charset="-120"/>
-              </a:rPr>
-              <a:t>2</a:t>
-            </a:r>
-            <a:endParaRPr lang="en-US" sz="1300" dirty="0"/>
-          </a:p>
-        </p:txBody>
-      </p:sp>
-      <p:sp>
-        <p:nvSpPr>
-          <p:cNvPr id="13" name="Text 11"/>
-          <p:cNvSpPr/>
-          <p:nvPr/>
-        </p:nvSpPr>
-        <p:spPr>
-          <a:xfrm>
-            <a:off x="1316736" y="2980944"/>
-            <a:ext cx="10149840" cy="274320"/>
-          </a:xfrm>
-          <a:prstGeom prst="rect">
-            <a:avLst/>
-          </a:prstGeom>
-          <a:noFill/>
-          <a:ln/>
-        </p:spPr>
-        <p:txBody>
-          <a:bodyPr wrap="square" lIns="0" tIns="0" rIns="0" bIns="0" rtlCol="0" anchor="ctr"/>
-          <a:lstStyle/>
-          <a:p>
-            <a:pPr indent="0" marL="0">
-              <a:buNone/>
-            </a:pPr>
-            <a:r>
-              <a:rPr lang="en-US" sz="1300" b="1" dirty="0">
-                <a:solidFill>
-                  <a:srgbClr val="1F3B57"/>
-                </a:solidFill>
-                <a:latin typeface="Arial" pitchFamily="34" charset="0"/>
-                <a:ea typeface="Arial" pitchFamily="34" charset="-122"/>
-                <a:cs typeface="Arial" pitchFamily="34" charset="-120"/>
-              </a:rPr>
-              <a:t>실현 성능이 아직 오라클 상한에 크게 못 미친다</a:t>
-            </a:r>
-            <a:endParaRPr lang="en-US" sz="1300" dirty="0"/>
-          </a:p>
-        </p:txBody>
-      </p:sp>
-      <p:sp>
-        <p:nvSpPr>
-          <p:cNvPr id="14" name="Text 12"/>
-          <p:cNvSpPr/>
-          <p:nvPr/>
-        </p:nvSpPr>
-        <p:spPr>
-          <a:xfrm>
-            <a:off x="1316736" y="3291840"/>
-            <a:ext cx="10149840" cy="548640"/>
-          </a:xfrm>
-          <a:prstGeom prst="rect">
-            <a:avLst/>
-          </a:prstGeom>
-          <a:noFill/>
-          <a:ln/>
-        </p:spPr>
-        <p:txBody>
-          <a:bodyPr wrap="square" lIns="0" tIns="0" rIns="0" bIns="0" rtlCol="0" anchor="ctr"/>
-          <a:lstStyle/>
-          <a:p>
-            <a:pPr indent="0" marL="0">
-              <a:lnSpc>
-                <a:spcPct val="115000"/>
-              </a:lnSpc>
-              <a:buNone/>
-            </a:pPr>
-            <a:r>
-              <a:rPr lang="en-US" sz="1100" dirty="0">
-                <a:solidFill>
-                  <a:srgbClr val="1F3B57"/>
-                </a:solidFill>
-                <a:latin typeface="Arial" pitchFamily="34" charset="0"/>
-                <a:ea typeface="Arial" pitchFamily="34" charset="-122"/>
-                <a:cs typeface="Arial" pitchFamily="34" charset="-120"/>
-              </a:rPr>
-              <a:t>N=3에서 오라클 0.904 vs 실현 0.703. 손상의 절반만 회수합니다.</a:t>
-            </a:r>
-            <a:endParaRPr lang="en-US" sz="1100" dirty="0"/>
-          </a:p>
-          <a:p>
-            <a:pPr indent="0" marL="0">
-              <a:lnSpc>
-                <a:spcPct val="115000"/>
-              </a:lnSpc>
-              <a:buNone/>
-            </a:pPr>
-            <a:r>
-              <a:rPr lang="en-US" sz="1100" dirty="0">
-                <a:solidFill>
-                  <a:srgbClr val="1F3B57"/>
-                </a:solidFill>
-                <a:latin typeface="Arial" pitchFamily="34" charset="0"/>
-                <a:ea typeface="Arial" pitchFamily="34" charset="-122"/>
-                <a:cs typeface="Arial" pitchFamily="34" charset="-120"/>
-              </a:rPr>
-              <a:t>그리고 forward N+1회라 효율 이득이 없습니다.</a:t>
-            </a:r>
-            <a:endParaRPr lang="en-US" sz="1100" dirty="0"/>
-          </a:p>
-        </p:txBody>
-      </p:sp>
-      <p:sp>
-        <p:nvSpPr>
-          <p:cNvPr id="15" name="Text 13"/>
-          <p:cNvSpPr/>
-          <p:nvPr/>
-        </p:nvSpPr>
-        <p:spPr>
-          <a:xfrm>
-            <a:off x="1316736" y="3877056"/>
-            <a:ext cx="10149840" cy="274320"/>
-          </a:xfrm>
-          <a:prstGeom prst="rect">
-            <a:avLst/>
-          </a:prstGeom>
-          <a:noFill/>
-          <a:ln/>
-        </p:spPr>
-        <p:txBody>
-          <a:bodyPr wrap="square" lIns="0" tIns="0" rIns="0" bIns="0" rtlCol="0" anchor="ctr"/>
-          <a:lstStyle/>
-          <a:p>
-            <a:pPr indent="0" marL="0">
-              <a:buNone/>
-            </a:pPr>
-            <a:r>
-              <a:rPr lang="en-US" sz="1100" b="1" dirty="0">
-                <a:solidFill>
-                  <a:srgbClr val="2E8B57"/>
-                </a:solidFill>
-                <a:latin typeface="Arial" pitchFamily="34" charset="0"/>
-                <a:ea typeface="Arial" pitchFamily="34" charset="-122"/>
-                <a:cs typeface="Arial" pitchFamily="34" charset="-120"/>
-              </a:rPr>
-              <a:t>대응: 컨트롤러 신호 개선 + 소프트 개입(λ)으로 오판 비용 완화</a:t>
-            </a:r>
-            <a:endParaRPr lang="en-US" sz="1100" dirty="0"/>
-          </a:p>
-        </p:txBody>
-      </p:sp>
-      <p:sp>
-        <p:nvSpPr>
-          <p:cNvPr id="16" name="Shape 14"/>
-          <p:cNvSpPr/>
-          <p:nvPr/>
-        </p:nvSpPr>
-        <p:spPr>
-          <a:xfrm>
-            <a:off x="502920" y="4370832"/>
-            <a:ext cx="11201400" cy="1408176"/>
-          </a:xfrm>
-          <a:prstGeom prst="roundRect">
-            <a:avLst>
-              <a:gd name="adj" fmla="val 5195"/>
-            </a:avLst>
-          </a:prstGeom>
-          <a:solidFill>
-            <a:srgbClr val="FBEAEA"/>
-          </a:solidFill>
-          <a:ln w="12700">
-            <a:solidFill>
-              <a:srgbClr val="D62728"/>
-            </a:solidFill>
-            <a:prstDash val="solid"/>
-          </a:ln>
-        </p:spPr>
-      </p:sp>
-      <p:sp>
-        <p:nvSpPr>
-          <p:cNvPr id="17" name="Shape 15"/>
-          <p:cNvSpPr/>
-          <p:nvPr/>
-        </p:nvSpPr>
-        <p:spPr>
-          <a:xfrm>
-            <a:off x="749808" y="4535424"/>
-            <a:ext cx="402336" cy="402336"/>
-          </a:xfrm>
-          <a:prstGeom prst="ellipse">
-            <a:avLst/>
-          </a:prstGeom>
-          <a:solidFill>
-            <a:srgbClr val="D62728"/>
-          </a:solidFill>
-          <a:ln/>
-        </p:spPr>
-      </p:sp>
-      <p:sp>
-        <p:nvSpPr>
-          <p:cNvPr id="18" name="Text 16"/>
-          <p:cNvSpPr/>
-          <p:nvPr/>
-        </p:nvSpPr>
-        <p:spPr>
-          <a:xfrm>
-            <a:off x="749808" y="4535424"/>
-            <a:ext cx="402336" cy="402336"/>
-          </a:xfrm>
-          <a:prstGeom prst="rect">
-            <a:avLst/>
-          </a:prstGeom>
-          <a:noFill/>
-          <a:ln/>
-        </p:spPr>
-        <p:txBody>
-          <a:bodyPr wrap="square" lIns="0" tIns="0" rIns="0" bIns="0" rtlCol="0" anchor="ctr"/>
-          <a:lstStyle/>
-          <a:p>
-            <a:pPr algn="ctr" indent="0" marL="0">
-              <a:buNone/>
-            </a:pPr>
-            <a:r>
-              <a:rPr lang="en-US" sz="1300" b="1" dirty="0">
-                <a:solidFill>
-                  <a:srgbClr val="FFFFFF"/>
-                </a:solidFill>
-                <a:latin typeface="Arial" pitchFamily="34" charset="0"/>
-                <a:ea typeface="Arial" pitchFamily="34" charset="-122"/>
-                <a:cs typeface="Arial" pitchFamily="34" charset="-120"/>
-              </a:rPr>
-              <a:t>3</a:t>
-            </a:r>
-            <a:endParaRPr lang="en-US" sz="1300" dirty="0"/>
-          </a:p>
-        </p:txBody>
-      </p:sp>
-      <p:sp>
-        <p:nvSpPr>
-          <p:cNvPr id="19" name="Text 17"/>
-          <p:cNvSpPr/>
-          <p:nvPr/>
-        </p:nvSpPr>
-        <p:spPr>
-          <a:xfrm>
-            <a:off x="1316736" y="4517136"/>
-            <a:ext cx="10149840" cy="274320"/>
-          </a:xfrm>
-          <a:prstGeom prst="rect">
-            <a:avLst/>
-          </a:prstGeom>
-          <a:noFill/>
-          <a:ln/>
-        </p:spPr>
-        <p:txBody>
-          <a:bodyPr wrap="square" lIns="0" tIns="0" rIns="0" bIns="0" rtlCol="0" anchor="ctr"/>
-          <a:lstStyle/>
-          <a:p>
-            <a:pPr indent="0" marL="0">
-              <a:buNone/>
-            </a:pPr>
-            <a:r>
-              <a:rPr lang="en-US" sz="1300" b="1" dirty="0">
-                <a:solidFill>
-                  <a:srgbClr val="1F3B57"/>
-                </a:solidFill>
-                <a:latin typeface="Arial" pitchFamily="34" charset="0"/>
-                <a:ea typeface="Arial" pitchFamily="34" charset="-122"/>
-                <a:cs typeface="Arial" pitchFamily="34" charset="-120"/>
-              </a:rPr>
-              <a:t>표준 벤치마크에서 아직 보이지 않았다</a:t>
-            </a:r>
-            <a:endParaRPr lang="en-US" sz="1300" dirty="0"/>
-          </a:p>
-        </p:txBody>
-      </p:sp>
-      <p:sp>
-        <p:nvSpPr>
-          <p:cNvPr id="20" name="Text 18"/>
-          <p:cNvSpPr/>
-          <p:nvPr/>
-        </p:nvSpPr>
-        <p:spPr>
-          <a:xfrm>
-            <a:off x="1316736" y="4828032"/>
-            <a:ext cx="10149840" cy="548640"/>
-          </a:xfrm>
-          <a:prstGeom prst="rect">
-            <a:avLst/>
-          </a:prstGeom>
-          <a:noFill/>
-          <a:ln/>
-        </p:spPr>
-        <p:txBody>
-          <a:bodyPr wrap="square" lIns="0" tIns="0" rIns="0" bIns="0" rtlCol="0" anchor="ctr"/>
-          <a:lstStyle/>
-          <a:p>
-            <a:pPr indent="0" marL="0">
-              <a:lnSpc>
-                <a:spcPct val="115000"/>
-              </a:lnSpc>
-              <a:buNone/>
-            </a:pPr>
-            <a:r>
-              <a:rPr lang="en-US" sz="1100" dirty="0">
-                <a:solidFill>
-                  <a:srgbClr val="1F3B57"/>
-                </a:solidFill>
-                <a:latin typeface="Arial" pitchFamily="34" charset="0"/>
-                <a:ea typeface="Arial" pitchFamily="34" charset="-122"/>
-                <a:cs typeface="Arial" pitchFamily="34" charset="-120"/>
-              </a:rPr>
-              <a:t>CAPL은 "추론시 attention 수정만으로는 일시적 개선"이라고 선점 반론을 폈습니다.</a:t>
-            </a:r>
-            <a:endParaRPr lang="en-US" sz="1100" dirty="0"/>
-          </a:p>
-          <a:p>
-            <a:pPr indent="0" marL="0">
-              <a:lnSpc>
-                <a:spcPct val="115000"/>
-              </a:lnSpc>
-              <a:buNone/>
-            </a:pPr>
-            <a:r>
-              <a:rPr lang="en-US" sz="1100" dirty="0">
-                <a:solidFill>
-                  <a:srgbClr val="1F3B57"/>
-                </a:solidFill>
-                <a:latin typeface="Arial" pitchFamily="34" charset="0"/>
-                <a:ea typeface="Arial" pitchFamily="34" charset="-122"/>
-                <a:cs typeface="Arial" pitchFamily="34" charset="-120"/>
-              </a:rPr>
-              <a:t>BLINK·MUIRBench 같은 공개 벤치에서 재현해야 이 반론을 막습니다.</a:t>
-            </a:r>
-            <a:endParaRPr lang="en-US" sz="1100" dirty="0"/>
-          </a:p>
-        </p:txBody>
-      </p:sp>
-      <p:sp>
-        <p:nvSpPr>
-          <p:cNvPr id="21" name="Text 19"/>
-          <p:cNvSpPr/>
-          <p:nvPr/>
-        </p:nvSpPr>
-        <p:spPr>
-          <a:xfrm>
-            <a:off x="1316736" y="5413248"/>
-            <a:ext cx="10149840" cy="274320"/>
-          </a:xfrm>
-          <a:prstGeom prst="rect">
-            <a:avLst/>
-          </a:prstGeom>
-          <a:noFill/>
-          <a:ln/>
-        </p:spPr>
-        <p:txBody>
-          <a:bodyPr wrap="square" lIns="0" tIns="0" rIns="0" bIns="0" rtlCol="0" anchor="ctr"/>
-          <a:lstStyle/>
-          <a:p>
-            <a:pPr indent="0" marL="0">
-              <a:buNone/>
-            </a:pPr>
-            <a:r>
-              <a:rPr lang="en-US" sz="1100" b="1" dirty="0">
-                <a:solidFill>
-                  <a:srgbClr val="2E8B57"/>
-                </a:solidFill>
-                <a:latin typeface="Arial" pitchFamily="34" charset="0"/>
-                <a:ea typeface="Arial" pitchFamily="34" charset="-122"/>
-                <a:cs typeface="Arial" pitchFamily="34" charset="-120"/>
-              </a:rPr>
-              <a:t>대응: 다음 단계 1순위</a:t>
-            </a:r>
-            <a:endParaRPr lang="en-US" sz="1100" dirty="0"/>
-          </a:p>
-        </p:txBody>
-      </p:sp>
-      <p:sp>
-        <p:nvSpPr>
-          <p:cNvPr id="22" name="Shape 20"/>
-          <p:cNvSpPr/>
-          <p:nvPr/>
-        </p:nvSpPr>
-        <p:spPr>
-          <a:xfrm>
-            <a:off x="502920" y="6053328"/>
-            <a:ext cx="11201400" cy="548640"/>
-          </a:xfrm>
-          <a:prstGeom prst="roundRect">
-            <a:avLst>
-              <a:gd name="adj" fmla="val 13333"/>
-            </a:avLst>
-          </a:prstGeom>
-          <a:solidFill>
-            <a:srgbClr val="1F3B57"/>
-          </a:solidFill>
-          <a:ln/>
-        </p:spPr>
-      </p:sp>
-      <p:sp>
-        <p:nvSpPr>
-          <p:cNvPr id="23" name="Text 21"/>
-          <p:cNvSpPr/>
-          <p:nvPr/>
-        </p:nvSpPr>
-        <p:spPr>
-          <a:xfrm>
-            <a:off x="777240" y="6053328"/>
-            <a:ext cx="10744200" cy="548640"/>
-          </a:xfrm>
-          <a:prstGeom prst="rect">
-            <a:avLst/>
-          </a:prstGeom>
-          <a:noFill/>
-          <a:ln/>
-        </p:spPr>
-        <p:txBody>
-          <a:bodyPr wrap="square" lIns="0" tIns="0" rIns="0" bIns="0" rtlCol="0" anchor="ctr"/>
-          <a:lstStyle/>
-          <a:p>
-            <a:pPr indent="0" marL="0">
-              <a:buNone/>
-            </a:pPr>
-            <a:r>
-              <a:rPr lang="en-US" sz="1250" b="1" dirty="0">
-                <a:solidFill>
-                  <a:srgbClr val="FFFFFF"/>
-                </a:solidFill>
-                <a:latin typeface="Arial" pitchFamily="34" charset="0"/>
-                <a:ea typeface="Arial" pitchFamily="34" charset="-122"/>
-                <a:cs typeface="Arial" pitchFamily="34" charset="-120"/>
-              </a:rPr>
-              <a:t>→ 셋 다 알고 있고, 셋 다 측정으로 답할 수 있습니다</a:t>
             </a:r>
             <a:endParaRPr lang="en-US" sz="1250" dirty="0"/>
           </a:p>

</xml_diff>